<commit_message>
feat(class-02): 新增 K8s vs OpenShift (OCP) 比較（含 Pros/Cons）＋投影片 9-10 頁
</commit_message>
<xml_diff>
--- a/01-class-slides/class-02-k8s-core.pptx
+++ b/01-class-slides/class-02-k8s-core.pptx
@@ -14,9 +14,11 @@
     <p:sldId id="262" r:id="rId8"/>
     <p:sldId id="263" r:id="rId9"/>
     <p:sldId id="264" r:id="rId10"/>
+    <p:sldId id="265" r:id="rId11"/>
+    <p:sldId id="266" r:id="rId12"/>
   </p:sldIdLst>
   <p:notesMasterIdLst>
-    <p:notesMasterId r:id="rId11"/>
+    <p:notesMasterId r:id="rId13"/>
   </p:notesMasterIdLst>
   <p:sldSz cx="9144000" cy="5143500"/>
   <p:notesSz cx="5143500" cy="9144000"/>
@@ -552,6 +554,182 @@
 </p:notes>
 </file>
 
+<file path=ppt/notesSlides/notesSlide10.xml><?xml version="1.0" encoding="utf-8"?>
+<p:notes xmlns:a="http://schemas.openxmlformats.org/drawingml/2006/main" xmlns:r="http://schemas.openxmlformats.org/officeDocument/2006/relationships" xmlns:p="http://schemas.openxmlformats.org/presentationml/2006/main">
+  <p:cSld>
+    <p:spTree>
+      <p:nvGrpSpPr>
+        <p:cNvPr id="1" name=""/>
+        <p:cNvGrpSpPr/>
+        <p:nvPr/>
+      </p:nvGrpSpPr>
+      <p:grpSpPr>
+        <a:xfrm>
+          <a:off x="0" y="0"/>
+          <a:ext cx="0" cy="0"/>
+          <a:chOff x="0" y="0"/>
+          <a:chExt cx="0" cy="0"/>
+        </a:xfrm>
+      </p:grpSpPr>
+      <p:sp>
+        <p:nvSpPr>
+          <p:cNvPr id="2" name="Slide Image Placeholder 1"/>
+          <p:cNvSpPr>
+            <a:spLocks noGrp="1" noRot="1" noChangeAspect="1"/>
+          </p:cNvSpPr>
+          <p:nvPr>
+            <p:ph type="sldImg"/>
+          </p:nvPr>
+        </p:nvSpPr>
+        <p:spPr/>
+      </p:sp>
+      <p:sp>
+        <p:nvSpPr>
+          <p:cNvPr id="3" name="Notes Placeholder 2"/>
+          <p:cNvSpPr>
+            <a:spLocks noGrp="1"/>
+          </p:cNvSpPr>
+          <p:nvPr>
+            <p:ph type="body" idx="1"/>
+          </p:nvPr>
+        </p:nvSpPr>
+        <p:spPr/>
+        <p:txBody>
+          <a:bodyPr/>
+          <a:lstStyle/>
+          <a:p>
+            <a:r>
+              <a:rPr lang="en-US" dirty="0"/>
+              <a:t/>
+            </a:r>
+            <a:endParaRPr lang="en-US" dirty="0"/>
+          </a:p>
+        </p:txBody>
+      </p:sp>
+      <p:sp>
+        <p:nvSpPr>
+          <p:cNvPr id="4" name="Slide Number Placeholder 3"/>
+          <p:cNvSpPr>
+            <a:spLocks noGrp="1"/>
+          </p:cNvSpPr>
+          <p:nvPr>
+            <p:ph type="sldNum" sz="quarter" idx="10"/>
+          </p:nvPr>
+        </p:nvSpPr>
+        <p:spPr/>
+        <p:txBody>
+          <a:bodyPr/>
+          <a:lstStyle/>
+          <a:p>
+            <a:fld id="{F7021451-1387-4CA6-816F-3879F97B5CBC}" type="slidenum">
+              <a:rPr lang="en-US"/>
+              <a:t>10</a:t>
+            </a:fld>
+            <a:endParaRPr lang="en-US"/>
+          </a:p>
+        </p:txBody>
+      </p:sp>
+    </p:spTree>
+    <p:extLst>
+      <p:ext uri="{BB962C8B-B14F-4D97-AF65-F5344CB8AC3E}">
+        <p14:creationId xmlns:p14="http://schemas.microsoft.com/office/powerpoint/2010/main" val="1024086991"/>
+      </p:ext>
+    </p:extLst>
+  </p:cSld>
+  <p:clrMapOvr>
+    <a:masterClrMapping/>
+  </p:clrMapOvr>
+</p:notes>
+</file>
+
+<file path=ppt/notesSlides/notesSlide11.xml><?xml version="1.0" encoding="utf-8"?>
+<p:notes xmlns:a="http://schemas.openxmlformats.org/drawingml/2006/main" xmlns:r="http://schemas.openxmlformats.org/officeDocument/2006/relationships" xmlns:p="http://schemas.openxmlformats.org/presentationml/2006/main">
+  <p:cSld>
+    <p:spTree>
+      <p:nvGrpSpPr>
+        <p:cNvPr id="1" name=""/>
+        <p:cNvGrpSpPr/>
+        <p:nvPr/>
+      </p:nvGrpSpPr>
+      <p:grpSpPr>
+        <a:xfrm>
+          <a:off x="0" y="0"/>
+          <a:ext cx="0" cy="0"/>
+          <a:chOff x="0" y="0"/>
+          <a:chExt cx="0" cy="0"/>
+        </a:xfrm>
+      </p:grpSpPr>
+      <p:sp>
+        <p:nvSpPr>
+          <p:cNvPr id="2" name="Slide Image Placeholder 1"/>
+          <p:cNvSpPr>
+            <a:spLocks noGrp="1" noRot="1" noChangeAspect="1"/>
+          </p:cNvSpPr>
+          <p:nvPr>
+            <p:ph type="sldImg"/>
+          </p:nvPr>
+        </p:nvSpPr>
+        <p:spPr/>
+      </p:sp>
+      <p:sp>
+        <p:nvSpPr>
+          <p:cNvPr id="3" name="Notes Placeholder 2"/>
+          <p:cNvSpPr>
+            <a:spLocks noGrp="1"/>
+          </p:cNvSpPr>
+          <p:nvPr>
+            <p:ph type="body" idx="1"/>
+          </p:nvPr>
+        </p:nvSpPr>
+        <p:spPr/>
+        <p:txBody>
+          <a:bodyPr/>
+          <a:lstStyle/>
+          <a:p>
+            <a:r>
+              <a:rPr lang="en-US" dirty="0"/>
+              <a:t>Wrap up, hand-off to Class 3.</a:t>
+            </a:r>
+            <a:endParaRPr lang="en-US" dirty="0"/>
+          </a:p>
+        </p:txBody>
+      </p:sp>
+      <p:sp>
+        <p:nvSpPr>
+          <p:cNvPr id="4" name="Slide Number Placeholder 3"/>
+          <p:cNvSpPr>
+            <a:spLocks noGrp="1"/>
+          </p:cNvSpPr>
+          <p:nvPr>
+            <p:ph type="sldNum" sz="quarter" idx="10"/>
+          </p:nvPr>
+        </p:nvSpPr>
+        <p:spPr/>
+        <p:txBody>
+          <a:bodyPr/>
+          <a:lstStyle/>
+          <a:p>
+            <a:fld id="{F7021451-1387-4CA6-816F-3879F97B5CBC}" type="slidenum">
+              <a:rPr lang="en-US"/>
+              <a:t>11</a:t>
+            </a:fld>
+            <a:endParaRPr lang="en-US"/>
+          </a:p>
+        </p:txBody>
+      </p:sp>
+    </p:spTree>
+    <p:extLst>
+      <p:ext uri="{BB962C8B-B14F-4D97-AF65-F5344CB8AC3E}">
+        <p14:creationId xmlns:p14="http://schemas.microsoft.com/office/powerpoint/2010/main" val="1024086991"/>
+      </p:ext>
+    </p:extLst>
+  </p:cSld>
+  <p:clrMapOvr>
+    <a:masterClrMapping/>
+  </p:clrMapOvr>
+</p:notes>
+</file>
+
 <file path=ppt/notesSlides/notesSlide2.xml><?xml version="1.0" encoding="utf-8"?>
 <p:notes xmlns:a="http://schemas.openxmlformats.org/drawingml/2006/main" xmlns:r="http://schemas.openxmlformats.org/officeDocument/2006/relationships" xmlns:p="http://schemas.openxmlformats.org/presentationml/2006/main">
   <p:cSld>
@@ -1214,7 +1392,7 @@
           <a:p>
             <a:r>
               <a:rPr lang="en-US" dirty="0"/>
-              <a:t>Wrap up, hand-off to Class 3.</a:t>
+              <a:t/>
             </a:r>
             <a:endParaRPr lang="en-US" dirty="0"/>
           </a:p>
@@ -1773,6 +1951,1044 @@
 </p:sld>
 </file>
 
+<file path=ppt/slides/slide10.xml><?xml version="1.0" encoding="utf-8"?>
+<p:sld xmlns:a="http://schemas.openxmlformats.org/drawingml/2006/main" xmlns:r="http://schemas.openxmlformats.org/officeDocument/2006/relationships" xmlns:p="http://schemas.openxmlformats.org/presentationml/2006/main">
+  <p:cSld name="Slide 10">
+    <p:bg>
+      <p:bgPr>
+        <a:solidFill>
+          <a:srgbClr val="FFFFFF"/>
+        </a:solidFill>
+      </p:bgPr>
+    </p:bg>
+    <p:spTree>
+      <p:nvGrpSpPr>
+        <p:cNvPr id="1" name=""/>
+        <p:cNvGrpSpPr/>
+        <p:nvPr/>
+      </p:nvGrpSpPr>
+      <p:grpSpPr>
+        <a:xfrm>
+          <a:off x="0" y="0"/>
+          <a:ext cx="0" cy="0"/>
+          <a:chOff x="0" y="0"/>
+          <a:chExt cx="0" cy="0"/>
+        </a:xfrm>
+      </p:grpSpPr>
+      <p:sp>
+        <p:nvSpPr>
+          <p:cNvPr id="2" name="Shape 0"/>
+          <p:cNvSpPr/>
+          <p:nvPr/>
+        </p:nvSpPr>
+        <p:spPr>
+          <a:xfrm>
+            <a:off x="502920" y="384048"/>
+            <a:ext cx="146304" cy="457200"/>
+          </a:xfrm>
+          <a:prstGeom prst="roundRect">
+            <a:avLst>
+              <a:gd name="adj" fmla="val 31250"/>
+            </a:avLst>
+          </a:prstGeom>
+          <a:solidFill>
+            <a:srgbClr val="FF7300"/>
+          </a:solidFill>
+          <a:ln/>
+        </p:spPr>
+      </p:sp>
+      <p:sp>
+        <p:nvSpPr>
+          <p:cNvPr id="3" name="Text 1"/>
+          <p:cNvSpPr/>
+          <p:nvPr/>
+        </p:nvSpPr>
+        <p:spPr>
+          <a:xfrm>
+            <a:off x="777240" y="274320"/>
+            <a:ext cx="7863840" cy="548640"/>
+          </a:xfrm>
+          <a:prstGeom prst="rect">
+            <a:avLst/>
+          </a:prstGeom>
+          <a:noFill/>
+          <a:ln/>
+        </p:spPr>
+        <p:txBody>
+          <a:bodyPr wrap="square" lIns="0" tIns="0" rIns="0" bIns="0" rtlCol="0" anchor="ctr"/>
+          <a:lstStyle/>
+          <a:p>
+            <a:pPr indent="0" marL="0">
+              <a:buNone/>
+            </a:pPr>
+            <a:r>
+              <a:rPr lang="en-US" sz="2800" b="1" dirty="0">
+                <a:solidFill>
+                  <a:srgbClr val="0E1B33"/>
+                </a:solidFill>
+                <a:latin typeface="Cambria" pitchFamily="34" charset="0"/>
+                <a:ea typeface="Cambria" pitchFamily="34" charset="-122"/>
+                <a:cs typeface="Cambria" pitchFamily="34" charset="-120"/>
+              </a:rPr>
+              <a:t>OCP 比較：優點 vs 缺點</a:t>
+            </a:r>
+            <a:endParaRPr lang="en-US" sz="2800" dirty="0"/>
+          </a:p>
+        </p:txBody>
+      </p:sp>
+      <p:sp>
+        <p:nvSpPr>
+          <p:cNvPr id="4" name="Text 2"/>
+          <p:cNvSpPr/>
+          <p:nvPr/>
+        </p:nvSpPr>
+        <p:spPr>
+          <a:xfrm>
+            <a:off x="8412480" y="320040"/>
+            <a:ext cx="548640" cy="365760"/>
+          </a:xfrm>
+          <a:prstGeom prst="rect">
+            <a:avLst/>
+          </a:prstGeom>
+          <a:noFill/>
+          <a:ln/>
+        </p:spPr>
+        <p:txBody>
+          <a:bodyPr wrap="square" lIns="0" tIns="0" rIns="0" bIns="0" rtlCol="0" anchor="ctr"/>
+          <a:lstStyle/>
+          <a:p>
+            <a:pPr algn="r" indent="0" marL="0">
+              <a:buNone/>
+            </a:pPr>
+            <a:r>
+              <a:rPr lang="en-US" sz="1200" dirty="0">
+                <a:solidFill>
+                  <a:srgbClr val="5A6B85"/>
+                </a:solidFill>
+                <a:latin typeface="Calibri" pitchFamily="34" charset="0"/>
+                <a:ea typeface="Calibri" pitchFamily="34" charset="-122"/>
+                <a:cs typeface="Calibri" pitchFamily="34" charset="-120"/>
+              </a:rPr>
+              <a:t>10</a:t>
+            </a:r>
+            <a:endParaRPr lang="en-US" sz="1200" dirty="0"/>
+          </a:p>
+        </p:txBody>
+      </p:sp>
+      <p:sp>
+        <p:nvSpPr>
+          <p:cNvPr id="5" name="Shape 3"/>
+          <p:cNvSpPr/>
+          <p:nvPr/>
+        </p:nvSpPr>
+        <p:spPr>
+          <a:xfrm>
+            <a:off x="457200" y="1051560"/>
+            <a:ext cx="4023360" cy="2057400"/>
+          </a:xfrm>
+          <a:prstGeom prst="roundRect">
+            <a:avLst>
+              <a:gd name="adj" fmla="val 3556"/>
+            </a:avLst>
+          </a:prstGeom>
+          <a:solidFill>
+            <a:srgbClr val="F3F6FC"/>
+          </a:solidFill>
+          <a:ln w="9525">
+            <a:solidFill>
+              <a:srgbClr val="D8E0EE"/>
+            </a:solidFill>
+            <a:prstDash val="solid"/>
+          </a:ln>
+        </p:spPr>
+      </p:sp>
+      <p:sp>
+        <p:nvSpPr>
+          <p:cNvPr id="6" name="Shape 4"/>
+          <p:cNvSpPr/>
+          <p:nvPr/>
+        </p:nvSpPr>
+        <p:spPr>
+          <a:xfrm>
+            <a:off x="640080" y="1216152"/>
+            <a:ext cx="365760" cy="365760"/>
+          </a:xfrm>
+          <a:prstGeom prst="ellipse">
+            <a:avLst/>
+          </a:prstGeom>
+          <a:solidFill>
+            <a:srgbClr val="FF7300"/>
+          </a:solidFill>
+          <a:ln/>
+        </p:spPr>
+      </p:sp>
+      <p:sp>
+        <p:nvSpPr>
+          <p:cNvPr id="7" name="Shape 5"/>
+          <p:cNvSpPr/>
+          <p:nvPr/>
+        </p:nvSpPr>
+        <p:spPr>
+          <a:xfrm>
+            <a:off x="694944" y="1271016"/>
+            <a:ext cx="256032" cy="256032"/>
+          </a:xfrm>
+          <a:prstGeom prst="ellipse">
+            <a:avLst/>
+          </a:prstGeom>
+          <a:solidFill>
+            <a:srgbClr val="FFFFFF"/>
+          </a:solidFill>
+          <a:ln/>
+        </p:spPr>
+      </p:sp>
+      <p:sp>
+        <p:nvSpPr>
+          <p:cNvPr id="8" name="Text 6"/>
+          <p:cNvSpPr/>
+          <p:nvPr/>
+        </p:nvSpPr>
+        <p:spPr>
+          <a:xfrm>
+            <a:off x="1024128" y="1197864"/>
+            <a:ext cx="3337560" cy="365760"/>
+          </a:xfrm>
+          <a:prstGeom prst="rect">
+            <a:avLst/>
+          </a:prstGeom>
+          <a:noFill/>
+          <a:ln/>
+        </p:spPr>
+        <p:txBody>
+          <a:bodyPr wrap="square" lIns="0" tIns="0" rIns="0" bIns="0" rtlCol="0" anchor="ctr"/>
+          <a:lstStyle/>
+          <a:p>
+            <a:pPr indent="0" marL="0">
+              <a:buNone/>
+            </a:pPr>
+            <a:r>
+              <a:rPr lang="en-US" sz="1400" b="1" dirty="0">
+                <a:solidFill>
+                  <a:srgbClr val="0E1B33"/>
+                </a:solidFill>
+                <a:latin typeface="Calibri" pitchFamily="34" charset="0"/>
+                <a:ea typeface="Calibri" pitchFamily="34" charset="-122"/>
+                <a:cs typeface="Calibri" pitchFamily="34" charset="-120"/>
+              </a:rPr>
+              <a:t>Kubernetes（Vanilla）</a:t>
+            </a:r>
+            <a:endParaRPr lang="en-US" sz="1400" dirty="0"/>
+          </a:p>
+        </p:txBody>
+      </p:sp>
+      <p:sp>
+        <p:nvSpPr>
+          <p:cNvPr id="9" name="Text 7"/>
+          <p:cNvSpPr/>
+          <p:nvPr/>
+        </p:nvSpPr>
+        <p:spPr>
+          <a:xfrm>
+            <a:off x="640080" y="1618488"/>
+            <a:ext cx="3657600" cy="1399032"/>
+          </a:xfrm>
+          <a:prstGeom prst="rect">
+            <a:avLst/>
+          </a:prstGeom>
+          <a:noFill/>
+          <a:ln/>
+        </p:spPr>
+        <p:txBody>
+          <a:bodyPr wrap="square" lIns="0" tIns="0" rIns="0" bIns="0" rtlCol="0" anchor="t"/>
+          <a:lstStyle/>
+          <a:p>
+            <a:pPr indent="0" marL="0">
+              <a:lnSpc>
+                <a:spcPts val="1500"/>
+              </a:lnSpc>
+              <a:buNone/>
+            </a:pPr>
+            <a:r>
+              <a:rPr lang="en-US" sz="1100" dirty="0">
+                <a:solidFill>
+                  <a:srgbClr val="1F2A3D"/>
+                </a:solidFill>
+                <a:latin typeface="Calibri" pitchFamily="34" charset="0"/>
+                <a:ea typeface="Calibri" pitchFamily="34" charset="-122"/>
+                <a:cs typeface="Calibri" pitchFamily="34" charset="-120"/>
+              </a:rPr>
+              <a:t>Pros：免費開源 / 輕量客製 / 版本自主</a:t>
+            </a:r>
+            <a:endParaRPr lang="en-US" sz="1100" dirty="0"/>
+          </a:p>
+          <a:p>
+            <a:pPr indent="0" marL="0">
+              <a:lnSpc>
+                <a:spcPts val="1500"/>
+              </a:lnSpc>
+              <a:buNone/>
+            </a:pPr>
+            <a:r>
+              <a:rPr lang="en-US" sz="1100" dirty="0">
+                <a:solidFill>
+                  <a:srgbClr val="1F2A3D"/>
+                </a:solidFill>
+                <a:latin typeface="Calibri" pitchFamily="34" charset="0"/>
+                <a:ea typeface="Calibri" pitchFamily="34" charset="-122"/>
+                <a:cs typeface="Calibri" pitchFamily="34" charset="-120"/>
+              </a:rPr>
+              <a:t>Cons：CNI/監控/Ingress/RBAC 全要自組</a:t>
+            </a:r>
+            <a:endParaRPr lang="en-US" sz="1100" dirty="0"/>
+          </a:p>
+          <a:p>
+            <a:pPr indent="0" marL="0">
+              <a:lnSpc>
+                <a:spcPts val="1500"/>
+              </a:lnSpc>
+              <a:buNone/>
+            </a:pPr>
+            <a:r>
+              <a:rPr lang="en-US" sz="1100" dirty="0">
+                <a:solidFill>
+                  <a:srgbClr val="1F2A3D"/>
+                </a:solidFill>
+                <a:latin typeface="Calibri" pitchFamily="34" charset="0"/>
+                <a:ea typeface="Calibri" pitchFamily="34" charset="-122"/>
+                <a:cs typeface="Calibri" pitchFamily="34" charset="-120"/>
+              </a:rPr>
+              <a:t>無原廠支援、維運與升級成本高</a:t>
+            </a:r>
+            <a:endParaRPr lang="en-US" sz="1100" dirty="0"/>
+          </a:p>
+        </p:txBody>
+      </p:sp>
+      <p:sp>
+        <p:nvSpPr>
+          <p:cNvPr id="10" name="Shape 8"/>
+          <p:cNvSpPr/>
+          <p:nvPr/>
+        </p:nvSpPr>
+        <p:spPr>
+          <a:xfrm>
+            <a:off x="4663440" y="1051560"/>
+            <a:ext cx="4023360" cy="2057400"/>
+          </a:xfrm>
+          <a:prstGeom prst="roundRect">
+            <a:avLst>
+              <a:gd name="adj" fmla="val 3556"/>
+            </a:avLst>
+          </a:prstGeom>
+          <a:solidFill>
+            <a:srgbClr val="F3F6FC"/>
+          </a:solidFill>
+          <a:ln w="9525">
+            <a:solidFill>
+              <a:srgbClr val="D8E0EE"/>
+            </a:solidFill>
+            <a:prstDash val="solid"/>
+          </a:ln>
+        </p:spPr>
+      </p:sp>
+      <p:sp>
+        <p:nvSpPr>
+          <p:cNvPr id="11" name="Shape 9"/>
+          <p:cNvSpPr/>
+          <p:nvPr/>
+        </p:nvSpPr>
+        <p:spPr>
+          <a:xfrm>
+            <a:off x="4846320" y="1216152"/>
+            <a:ext cx="365760" cy="365760"/>
+          </a:xfrm>
+          <a:prstGeom prst="ellipse">
+            <a:avLst/>
+          </a:prstGeom>
+          <a:solidFill>
+            <a:srgbClr val="326CE5"/>
+          </a:solidFill>
+          <a:ln/>
+        </p:spPr>
+      </p:sp>
+      <p:sp>
+        <p:nvSpPr>
+          <p:cNvPr id="12" name="Shape 10"/>
+          <p:cNvSpPr/>
+          <p:nvPr/>
+        </p:nvSpPr>
+        <p:spPr>
+          <a:xfrm>
+            <a:off x="4901184" y="1271016"/>
+            <a:ext cx="256032" cy="256032"/>
+          </a:xfrm>
+          <a:prstGeom prst="ellipse">
+            <a:avLst/>
+          </a:prstGeom>
+          <a:solidFill>
+            <a:srgbClr val="FFFFFF"/>
+          </a:solidFill>
+          <a:ln/>
+        </p:spPr>
+      </p:sp>
+      <p:sp>
+        <p:nvSpPr>
+          <p:cNvPr id="13" name="Text 11"/>
+          <p:cNvSpPr/>
+          <p:nvPr/>
+        </p:nvSpPr>
+        <p:spPr>
+          <a:xfrm>
+            <a:off x="5230368" y="1197864"/>
+            <a:ext cx="3337560" cy="365760"/>
+          </a:xfrm>
+          <a:prstGeom prst="rect">
+            <a:avLst/>
+          </a:prstGeom>
+          <a:noFill/>
+          <a:ln/>
+        </p:spPr>
+        <p:txBody>
+          <a:bodyPr wrap="square" lIns="0" tIns="0" rIns="0" bIns="0" rtlCol="0" anchor="ctr"/>
+          <a:lstStyle/>
+          <a:p>
+            <a:pPr indent="0" marL="0">
+              <a:buNone/>
+            </a:pPr>
+            <a:r>
+              <a:rPr lang="en-US" sz="1400" b="1" dirty="0">
+                <a:solidFill>
+                  <a:srgbClr val="0E1B33"/>
+                </a:solidFill>
+                <a:latin typeface="Calibri" pitchFamily="34" charset="0"/>
+                <a:ea typeface="Calibri" pitchFamily="34" charset="-122"/>
+                <a:cs typeface="Calibri" pitchFamily="34" charset="-120"/>
+              </a:rPr>
+              <a:t>OpenShift（OCP）</a:t>
+            </a:r>
+            <a:endParaRPr lang="en-US" sz="1400" dirty="0"/>
+          </a:p>
+        </p:txBody>
+      </p:sp>
+      <p:sp>
+        <p:nvSpPr>
+          <p:cNvPr id="14" name="Text 12"/>
+          <p:cNvSpPr/>
+          <p:nvPr/>
+        </p:nvSpPr>
+        <p:spPr>
+          <a:xfrm>
+            <a:off x="4846320" y="1618488"/>
+            <a:ext cx="3657600" cy="1399032"/>
+          </a:xfrm>
+          <a:prstGeom prst="rect">
+            <a:avLst/>
+          </a:prstGeom>
+          <a:noFill/>
+          <a:ln/>
+        </p:spPr>
+        <p:txBody>
+          <a:bodyPr wrap="square" lIns="0" tIns="0" rIns="0" bIns="0" rtlCol="0" anchor="t"/>
+          <a:lstStyle/>
+          <a:p>
+            <a:pPr indent="0" marL="0">
+              <a:lnSpc>
+                <a:spcPts val="1500"/>
+              </a:lnSpc>
+              <a:buNone/>
+            </a:pPr>
+            <a:r>
+              <a:rPr lang="en-US" sz="1100" dirty="0">
+                <a:solidFill>
+                  <a:srgbClr val="1F2A3D"/>
+                </a:solidFill>
+                <a:latin typeface="Calibri" pitchFamily="34" charset="0"/>
+                <a:ea typeface="Calibri" pitchFamily="34" charset="-122"/>
+                <a:cs typeface="Calibri" pitchFamily="34" charset="-120"/>
+              </a:rPr>
+              <a:t>Pros：企業一體化 / 支援與 SLA / 安全開箱即用</a:t>
+            </a:r>
+            <a:endParaRPr lang="en-US" sz="1100" dirty="0"/>
+          </a:p>
+          <a:p>
+            <a:pPr indent="0" marL="0">
+              <a:lnSpc>
+                <a:spcPts val="1500"/>
+              </a:lnSpc>
+              <a:buNone/>
+            </a:pPr>
+            <a:r>
+              <a:rPr lang="en-US" sz="1100" dirty="0">
+                <a:solidFill>
+                  <a:srgbClr val="1F2A3D"/>
+                </a:solidFill>
+                <a:latin typeface="Calibri" pitchFamily="34" charset="0"/>
+                <a:ea typeface="Calibri" pitchFamily="34" charset="-122"/>
+                <a:cs typeface="Calibri" pitchFamily="34" charset="-120"/>
+              </a:rPr>
+              <a:t>Cons：付費訂閱 / 較重耗資源 / 客製受限</a:t>
+            </a:r>
+            <a:endParaRPr lang="en-US" sz="1100" dirty="0"/>
+          </a:p>
+          <a:p>
+            <a:pPr indent="0" marL="0">
+              <a:lnSpc>
+                <a:spcPts val="1500"/>
+              </a:lnSpc>
+              <a:buNone/>
+            </a:pPr>
+            <a:r>
+              <a:rPr lang="en-US" sz="1100" dirty="0">
+                <a:solidFill>
+                  <a:srgbClr val="1F2A3D"/>
+                </a:solidFill>
+                <a:latin typeface="Calibri" pitchFamily="34" charset="0"/>
+                <a:ea typeface="Calibri" pitchFamily="34" charset="-122"/>
+                <a:cs typeface="Calibri" pitchFamily="34" charset="-120"/>
+              </a:rPr>
+              <a:t>綁定 Red Hat 節奏，免費版 OKD 無支援</a:t>
+            </a:r>
+            <a:endParaRPr lang="en-US" sz="1100" dirty="0"/>
+          </a:p>
+        </p:txBody>
+      </p:sp>
+      <p:sp>
+        <p:nvSpPr>
+          <p:cNvPr id="15" name="Shape 13"/>
+          <p:cNvSpPr/>
+          <p:nvPr/>
+        </p:nvSpPr>
+        <p:spPr>
+          <a:xfrm>
+            <a:off x="457200" y="3383280"/>
+            <a:ext cx="8229600" cy="475488"/>
+          </a:xfrm>
+          <a:prstGeom prst="roundRect">
+            <a:avLst>
+              <a:gd name="adj" fmla="val 15385"/>
+            </a:avLst>
+          </a:prstGeom>
+          <a:solidFill>
+            <a:srgbClr val="EAF1FF"/>
+          </a:solidFill>
+          <a:ln/>
+        </p:spPr>
+      </p:sp>
+      <p:sp>
+        <p:nvSpPr>
+          <p:cNvPr id="16" name="Text 14"/>
+          <p:cNvSpPr/>
+          <p:nvPr/>
+        </p:nvSpPr>
+        <p:spPr>
+          <a:xfrm>
+            <a:off x="594360" y="3438144"/>
+            <a:ext cx="2834640" cy="365760"/>
+          </a:xfrm>
+          <a:prstGeom prst="rect">
+            <a:avLst/>
+          </a:prstGeom>
+          <a:noFill/>
+          <a:ln/>
+        </p:spPr>
+        <p:txBody>
+          <a:bodyPr wrap="square" lIns="0" tIns="0" rIns="0" bIns="0" rtlCol="0" anchor="ctr"/>
+          <a:lstStyle/>
+          <a:p>
+            <a:pPr indent="0" marL="0">
+              <a:buNone/>
+            </a:pPr>
+            <a:r>
+              <a:rPr lang="en-US" sz="1300" b="1" dirty="0">
+                <a:solidFill>
+                  <a:srgbClr val="FF7300"/>
+                </a:solidFill>
+                <a:latin typeface="Calibri" pitchFamily="34" charset="0"/>
+                <a:ea typeface="Calibri" pitchFamily="34" charset="-122"/>
+                <a:cs typeface="Calibri" pitchFamily="34" charset="-120"/>
+              </a:rPr>
+              <a:t>訓練/研究/Lab →</a:t>
+            </a:r>
+            <a:endParaRPr lang="en-US" sz="1300" dirty="0"/>
+          </a:p>
+        </p:txBody>
+      </p:sp>
+      <p:sp>
+        <p:nvSpPr>
+          <p:cNvPr id="17" name="Text 15"/>
+          <p:cNvSpPr/>
+          <p:nvPr/>
+        </p:nvSpPr>
+        <p:spPr>
+          <a:xfrm>
+            <a:off x="3520440" y="3438144"/>
+            <a:ext cx="5029200" cy="365760"/>
+          </a:xfrm>
+          <a:prstGeom prst="rect">
+            <a:avLst/>
+          </a:prstGeom>
+          <a:noFill/>
+          <a:ln/>
+        </p:spPr>
+        <p:txBody>
+          <a:bodyPr wrap="square" lIns="0" tIns="0" rIns="0" bIns="0" rtlCol="0" anchor="ctr"/>
+          <a:lstStyle/>
+          <a:p>
+            <a:pPr indent="0" marL="0">
+              <a:buNone/>
+            </a:pPr>
+            <a:r>
+              <a:rPr lang="en-US" sz="1300" dirty="0">
+                <a:solidFill>
+                  <a:srgbClr val="0E1B33"/>
+                </a:solidFill>
+                <a:latin typeface="Calibri" pitchFamily="34" charset="0"/>
+                <a:ea typeface="Calibri" pitchFamily="34" charset="-122"/>
+                <a:cs typeface="Calibri" pitchFamily="34" charset="-120"/>
+              </a:rPr>
+              <a:t>Vanilla Kubernetes（零成本、看透原理）</a:t>
+            </a:r>
+            <a:endParaRPr lang="en-US" sz="1300" dirty="0"/>
+          </a:p>
+        </p:txBody>
+      </p:sp>
+      <p:sp>
+        <p:nvSpPr>
+          <p:cNvPr id="18" name="Shape 16"/>
+          <p:cNvSpPr/>
+          <p:nvPr/>
+        </p:nvSpPr>
+        <p:spPr>
+          <a:xfrm>
+            <a:off x="457200" y="3931920"/>
+            <a:ext cx="8229600" cy="475488"/>
+          </a:xfrm>
+          <a:prstGeom prst="roundRect">
+            <a:avLst>
+              <a:gd name="adj" fmla="val 15385"/>
+            </a:avLst>
+          </a:prstGeom>
+          <a:solidFill>
+            <a:srgbClr val="EAF1FF"/>
+          </a:solidFill>
+          <a:ln/>
+        </p:spPr>
+      </p:sp>
+      <p:sp>
+        <p:nvSpPr>
+          <p:cNvPr id="19" name="Text 17"/>
+          <p:cNvSpPr/>
+          <p:nvPr/>
+        </p:nvSpPr>
+        <p:spPr>
+          <a:xfrm>
+            <a:off x="594360" y="3986784"/>
+            <a:ext cx="2834640" cy="365760"/>
+          </a:xfrm>
+          <a:prstGeom prst="rect">
+            <a:avLst/>
+          </a:prstGeom>
+          <a:noFill/>
+          <a:ln/>
+        </p:spPr>
+        <p:txBody>
+          <a:bodyPr wrap="square" lIns="0" tIns="0" rIns="0" bIns="0" rtlCol="0" anchor="ctr"/>
+          <a:lstStyle/>
+          <a:p>
+            <a:pPr indent="0" marL="0">
+              <a:buNone/>
+            </a:pPr>
+            <a:r>
+              <a:rPr lang="en-US" sz="1300" b="1" dirty="0">
+                <a:solidFill>
+                  <a:srgbClr val="FF7300"/>
+                </a:solidFill>
+                <a:latin typeface="Calibri" pitchFamily="34" charset="0"/>
+                <a:ea typeface="Calibri" pitchFamily="34" charset="-122"/>
+                <a:cs typeface="Calibri" pitchFamily="34" charset="-120"/>
+              </a:rPr>
+              <a:t>企業上線/需合規 →</a:t>
+            </a:r>
+            <a:endParaRPr lang="en-US" sz="1300" dirty="0"/>
+          </a:p>
+        </p:txBody>
+      </p:sp>
+      <p:sp>
+        <p:nvSpPr>
+          <p:cNvPr id="20" name="Text 18"/>
+          <p:cNvSpPr/>
+          <p:nvPr/>
+        </p:nvSpPr>
+        <p:spPr>
+          <a:xfrm>
+            <a:off x="3520440" y="3986784"/>
+            <a:ext cx="5029200" cy="365760"/>
+          </a:xfrm>
+          <a:prstGeom prst="rect">
+            <a:avLst/>
+          </a:prstGeom>
+          <a:noFill/>
+          <a:ln/>
+        </p:spPr>
+        <p:txBody>
+          <a:bodyPr wrap="square" lIns="0" tIns="0" rIns="0" bIns="0" rtlCol="0" anchor="ctr"/>
+          <a:lstStyle/>
+          <a:p>
+            <a:pPr indent="0" marL="0">
+              <a:buNone/>
+            </a:pPr>
+            <a:r>
+              <a:rPr lang="en-US" sz="1300" dirty="0">
+                <a:solidFill>
+                  <a:srgbClr val="0E1B33"/>
+                </a:solidFill>
+                <a:latin typeface="Calibri" pitchFamily="34" charset="0"/>
+                <a:ea typeface="Calibri" pitchFamily="34" charset="-122"/>
+                <a:cs typeface="Calibri" pitchFamily="34" charset="-120"/>
+              </a:rPr>
+              <a:t>OpenShift（付費買支援與一體化）</a:t>
+            </a:r>
+            <a:endParaRPr lang="en-US" sz="1300" dirty="0"/>
+          </a:p>
+        </p:txBody>
+      </p:sp>
+      <p:sp>
+        <p:nvSpPr>
+          <p:cNvPr id="21" name="Shape 19"/>
+          <p:cNvSpPr/>
+          <p:nvPr/>
+        </p:nvSpPr>
+        <p:spPr>
+          <a:xfrm>
+            <a:off x="457200" y="4480560"/>
+            <a:ext cx="8229600" cy="475488"/>
+          </a:xfrm>
+          <a:prstGeom prst="roundRect">
+            <a:avLst>
+              <a:gd name="adj" fmla="val 15385"/>
+            </a:avLst>
+          </a:prstGeom>
+          <a:solidFill>
+            <a:srgbClr val="EAF1FF"/>
+          </a:solidFill>
+          <a:ln/>
+        </p:spPr>
+      </p:sp>
+      <p:sp>
+        <p:nvSpPr>
+          <p:cNvPr id="22" name="Text 20"/>
+          <p:cNvSpPr/>
+          <p:nvPr/>
+        </p:nvSpPr>
+        <p:spPr>
+          <a:xfrm>
+            <a:off x="594360" y="4535424"/>
+            <a:ext cx="2834640" cy="365760"/>
+          </a:xfrm>
+          <a:prstGeom prst="rect">
+            <a:avLst/>
+          </a:prstGeom>
+          <a:noFill/>
+          <a:ln/>
+        </p:spPr>
+        <p:txBody>
+          <a:bodyPr wrap="square" lIns="0" tIns="0" rIns="0" bIns="0" rtlCol="0" anchor="ctr"/>
+          <a:lstStyle/>
+          <a:p>
+            <a:pPr indent="0" marL="0">
+              <a:buNone/>
+            </a:pPr>
+            <a:r>
+              <a:rPr lang="en-US" sz="1300" b="1" dirty="0">
+                <a:solidFill>
+                  <a:srgbClr val="FF7300"/>
+                </a:solidFill>
+                <a:latin typeface="Calibri" pitchFamily="34" charset="0"/>
+                <a:ea typeface="Calibri" pitchFamily="34" charset="-122"/>
+                <a:cs typeface="Calibri" pitchFamily="34" charset="-120"/>
+              </a:rPr>
+              <a:t>折衷 →</a:t>
+            </a:r>
+            <a:endParaRPr lang="en-US" sz="1300" dirty="0"/>
+          </a:p>
+        </p:txBody>
+      </p:sp>
+      <p:sp>
+        <p:nvSpPr>
+          <p:cNvPr id="23" name="Text 21"/>
+          <p:cNvSpPr/>
+          <p:nvPr/>
+        </p:nvSpPr>
+        <p:spPr>
+          <a:xfrm>
+            <a:off x="3520440" y="4535424"/>
+            <a:ext cx="5029200" cy="365760"/>
+          </a:xfrm>
+          <a:prstGeom prst="rect">
+            <a:avLst/>
+          </a:prstGeom>
+          <a:noFill/>
+          <a:ln/>
+        </p:spPr>
+        <p:txBody>
+          <a:bodyPr wrap="square" lIns="0" tIns="0" rIns="0" bIns="0" rtlCol="0" anchor="ctr"/>
+          <a:lstStyle/>
+          <a:p>
+            <a:pPr indent="0" marL="0">
+              <a:buNone/>
+            </a:pPr>
+            <a:r>
+              <a:rPr lang="en-US" sz="1300" dirty="0">
+                <a:solidFill>
+                  <a:srgbClr val="0E1B33"/>
+                </a:solidFill>
+                <a:latin typeface="Calibri" pitchFamily="34" charset="0"/>
+                <a:ea typeface="Calibri" pitchFamily="34" charset="-122"/>
+                <a:cs typeface="Calibri" pitchFamily="34" charset="-120"/>
+              </a:rPr>
+              <a:t>先打穩 K8s 原理，轉 OCP 僅換外皮</a:t>
+            </a:r>
+            <a:endParaRPr lang="en-US" sz="1300" dirty="0"/>
+          </a:p>
+        </p:txBody>
+      </p:sp>
+      <p:sp>
+        <p:nvSpPr>
+          <p:cNvPr id="24" name="Text 22"/>
+          <p:cNvSpPr/>
+          <p:nvPr/>
+        </p:nvSpPr>
+        <p:spPr>
+          <a:xfrm>
+            <a:off x="457200" y="4892040"/>
+            <a:ext cx="8229600" cy="228600"/>
+          </a:xfrm>
+          <a:prstGeom prst="rect">
+            <a:avLst/>
+          </a:prstGeom>
+          <a:noFill/>
+          <a:ln/>
+        </p:spPr>
+        <p:txBody>
+          <a:bodyPr wrap="square" lIns="0" tIns="0" rIns="0" bIns="0" rtlCol="0" anchor="ctr"/>
+          <a:lstStyle/>
+          <a:p>
+            <a:pPr indent="0" marL="0">
+              <a:buNone/>
+            </a:pPr>
+            <a:r>
+              <a:rPr lang="en-US" sz="900" dirty="0">
+                <a:solidFill>
+                  <a:srgbClr val="5A6B85"/>
+                </a:solidFill>
+                <a:latin typeface="Calibri" pitchFamily="34" charset="0"/>
+                <a:ea typeface="Calibri" pitchFamily="34" charset="-122"/>
+                <a:cs typeface="Calibri" pitchFamily="34" charset="-120"/>
+              </a:rPr>
+              <a:t>底層都是 K8s API；本課程以 Vanilla (kubeadm) 講透原理，OCP 只是企業層調味</a:t>
+            </a:r>
+            <a:endParaRPr lang="en-US" sz="900" dirty="0"/>
+          </a:p>
+        </p:txBody>
+      </p:sp>
+    </p:spTree>
+  </p:cSld>
+  <p:clrMapOvr>
+    <a:masterClrMapping/>
+  </p:clrMapOvr>
+</p:sld>
+</file>
+
+<file path=ppt/slides/slide11.xml><?xml version="1.0" encoding="utf-8"?>
+<p:sld xmlns:a="http://schemas.openxmlformats.org/drawingml/2006/main" xmlns:r="http://schemas.openxmlformats.org/officeDocument/2006/relationships" xmlns:p="http://schemas.openxmlformats.org/presentationml/2006/main">
+  <p:cSld name="Slide 11">
+    <p:bg>
+      <p:bgPr>
+        <a:solidFill>
+          <a:srgbClr val="0E1B33"/>
+        </a:solidFill>
+      </p:bgPr>
+    </p:bg>
+    <p:spTree>
+      <p:nvGrpSpPr>
+        <p:cNvPr id="1" name=""/>
+        <p:cNvGrpSpPr/>
+        <p:nvPr/>
+      </p:nvGrpSpPr>
+      <p:grpSpPr>
+        <a:xfrm>
+          <a:off x="0" y="0"/>
+          <a:ext cx="0" cy="0"/>
+          <a:chOff x="0" y="0"/>
+          <a:chExt cx="0" cy="0"/>
+        </a:xfrm>
+      </p:grpSpPr>
+      <p:sp>
+        <p:nvSpPr>
+          <p:cNvPr id="2" name="Text 0"/>
+          <p:cNvSpPr/>
+          <p:nvPr/>
+        </p:nvSpPr>
+        <p:spPr>
+          <a:xfrm>
+            <a:off x="548640" y="256032"/>
+            <a:ext cx="8046720" cy="274320"/>
+          </a:xfrm>
+          <a:prstGeom prst="rect">
+            <a:avLst/>
+          </a:prstGeom>
+          <a:noFill/>
+          <a:ln/>
+        </p:spPr>
+        <p:txBody>
+          <a:bodyPr wrap="square" lIns="0" tIns="0" rIns="0" bIns="0" rtlCol="0" anchor="ctr"/>
+          <a:lstStyle/>
+          <a:p>
+            <a:pPr indent="0" marL="0">
+              <a:buNone/>
+            </a:pPr>
+            <a:r>
+              <a:rPr lang="en-US" sz="1200" b="1" spc="200" kern="0" dirty="0">
+                <a:solidFill>
+                  <a:srgbClr val="FF7300"/>
+                </a:solidFill>
+                <a:latin typeface="Calibri" pitchFamily="34" charset="0"/>
+                <a:ea typeface="Calibri" pitchFamily="34" charset="-122"/>
+                <a:cs typeface="Calibri" pitchFamily="34" charset="-120"/>
+              </a:rPr>
+              <a:t>Class 2 · 完成</a:t>
+            </a:r>
+            <a:endParaRPr lang="en-US" sz="1200" dirty="0"/>
+          </a:p>
+        </p:txBody>
+      </p:sp>
+      <p:sp>
+        <p:nvSpPr>
+          <p:cNvPr id="3" name="Text 1"/>
+          <p:cNvSpPr/>
+          <p:nvPr/>
+        </p:nvSpPr>
+        <p:spPr>
+          <a:xfrm>
+            <a:off x="548640" y="640080"/>
+            <a:ext cx="8046720" cy="1005840"/>
+          </a:xfrm>
+          <a:prstGeom prst="rect">
+            <a:avLst/>
+          </a:prstGeom>
+          <a:noFill/>
+          <a:ln/>
+        </p:spPr>
+        <p:txBody>
+          <a:bodyPr wrap="square" lIns="0" tIns="0" rIns="0" bIns="0" rtlCol="0" anchor="ctr"/>
+          <a:lstStyle/>
+          <a:p>
+            <a:pPr indent="0" marL="0">
+              <a:buNone/>
+            </a:pPr>
+            <a:r>
+              <a:rPr lang="en-US" sz="4000" b="1" dirty="0">
+                <a:solidFill>
+                  <a:srgbClr val="FFFFFF"/>
+                </a:solidFill>
+                <a:latin typeface="Cambria" pitchFamily="34" charset="0"/>
+                <a:ea typeface="Cambria" pitchFamily="34" charset="-122"/>
+                <a:cs typeface="Cambria" pitchFamily="34" charset="-120"/>
+              </a:rPr>
+              <a:t>下一步：網路、儲存、高可用</a:t>
+            </a:r>
+            <a:endParaRPr lang="en-US" sz="4000" dirty="0"/>
+          </a:p>
+        </p:txBody>
+      </p:sp>
+      <p:sp>
+        <p:nvSpPr>
+          <p:cNvPr id="4" name="Text 2"/>
+          <p:cNvSpPr/>
+          <p:nvPr/>
+        </p:nvSpPr>
+        <p:spPr>
+          <a:xfrm>
+            <a:off x="548640" y="1463040"/>
+            <a:ext cx="7863840" cy="822960"/>
+          </a:xfrm>
+          <a:prstGeom prst="rect">
+            <a:avLst/>
+          </a:prstGeom>
+          <a:noFill/>
+          <a:ln/>
+        </p:spPr>
+        <p:txBody>
+          <a:bodyPr wrap="square" lIns="0" tIns="0" rIns="0" bIns="0" rtlCol="0" anchor="ctr"/>
+          <a:lstStyle/>
+          <a:p>
+            <a:pPr indent="0" marL="0">
+              <a:lnSpc>
+                <a:spcPts val="3000"/>
+              </a:lnSpc>
+              <a:buNone/>
+            </a:pPr>
+            <a:r>
+              <a:rPr lang="en-US" sz="1800" dirty="0">
+                <a:solidFill>
+                  <a:srgbClr val="CADCFC"/>
+                </a:solidFill>
+                <a:latin typeface="Calibri" pitchFamily="34" charset="0"/>
+                <a:ea typeface="Calibri" pitchFamily="34" charset="-122"/>
+                <a:cs typeface="Calibri" pitchFamily="34" charset="-120"/>
+              </a:rPr>
+              <a:t>了解 K8s 對外暴露、持久儲存與 HA 的原理。</a:t>
+            </a:r>
+            <a:endParaRPr lang="en-US" sz="1800" dirty="0"/>
+          </a:p>
+        </p:txBody>
+      </p:sp>
+      <p:sp>
+        <p:nvSpPr>
+          <p:cNvPr id="5" name="Text 3"/>
+          <p:cNvSpPr/>
+          <p:nvPr/>
+        </p:nvSpPr>
+        <p:spPr>
+          <a:xfrm>
+            <a:off x="548640" y="2926080"/>
+            <a:ext cx="7863840" cy="548640"/>
+          </a:xfrm>
+          <a:prstGeom prst="rect">
+            <a:avLst/>
+          </a:prstGeom>
+          <a:noFill/>
+          <a:ln/>
+        </p:spPr>
+        <p:txBody>
+          <a:bodyPr wrap="square" lIns="0" tIns="0" rIns="0" bIns="0" rtlCol="0" anchor="ctr"/>
+          <a:lstStyle/>
+          <a:p>
+            <a:pPr indent="0" marL="0">
+              <a:buNone/>
+            </a:pPr>
+            <a:r>
+              <a:rPr lang="en-US" sz="1400" dirty="0">
+                <a:solidFill>
+                  <a:srgbClr val="CADCFC"/>
+                </a:solidFill>
+                <a:latin typeface="Calibri" pitchFamily="34" charset="0"/>
+                <a:ea typeface="Calibri" pitchFamily="34" charset="-122"/>
+                <a:cs typeface="Calibri" pitchFamily="34" charset="-120"/>
+              </a:rPr>
+              <a:t>原理通了，接下來實作前先把基礎元件（CNI/儲存/HA）搞懂。</a:t>
+            </a:r>
+            <a:endParaRPr lang="en-US" sz="1400" dirty="0"/>
+          </a:p>
+        </p:txBody>
+      </p:sp>
+    </p:spTree>
+  </p:cSld>
+  <p:clrMapOvr>
+    <a:masterClrMapping/>
+  </p:clrMapOvr>
+</p:sld>
+</file>
+
 <file path=ppt/slides/slide2.xml><?xml version="1.0" encoding="utf-8"?>
 <p:sld xmlns:a="http://schemas.openxmlformats.org/drawingml/2006/main" xmlns:r="http://schemas.openxmlformats.org/officeDocument/2006/relationships" xmlns:p="http://schemas.openxmlformats.org/presentationml/2006/main">
   <p:cSld name="Slide 2">
@@ -7941,7 +9157,7 @@
     <p:bg>
       <p:bgPr>
         <a:solidFill>
-          <a:srgbClr val="0E1B33"/>
+          <a:srgbClr val="FFFFFF"/>
         </a:solidFill>
       </p:bgPr>
     </p:bg>
@@ -7961,14 +9177,36 @@
       </p:grpSpPr>
       <p:sp>
         <p:nvSpPr>
-          <p:cNvPr id="2" name="Text 0"/>
-          <p:cNvSpPr/>
-          <p:nvPr/>
-        </p:nvSpPr>
-        <p:spPr>
-          <a:xfrm>
-            <a:off x="548640" y="256032"/>
-            <a:ext cx="8046720" cy="274320"/>
+          <p:cNvPr id="2" name="Shape 0"/>
+          <p:cNvSpPr/>
+          <p:nvPr/>
+        </p:nvSpPr>
+        <p:spPr>
+          <a:xfrm>
+            <a:off x="502920" y="384048"/>
+            <a:ext cx="146304" cy="457200"/>
+          </a:xfrm>
+          <a:prstGeom prst="roundRect">
+            <a:avLst>
+              <a:gd name="adj" fmla="val 31250"/>
+            </a:avLst>
+          </a:prstGeom>
+          <a:solidFill>
+            <a:srgbClr val="FF7300"/>
+          </a:solidFill>
+          <a:ln/>
+        </p:spPr>
+      </p:sp>
+      <p:sp>
+        <p:nvSpPr>
+          <p:cNvPr id="3" name="Text 1"/>
+          <p:cNvSpPr/>
+          <p:nvPr/>
+        </p:nvSpPr>
+        <p:spPr>
+          <a:xfrm>
+            <a:off x="777240" y="274320"/>
+            <a:ext cx="7863840" cy="548640"/>
           </a:xfrm>
           <a:prstGeom prst="rect">
             <a:avLst/>
@@ -7984,56 +9222,17 @@
               <a:buNone/>
             </a:pPr>
             <a:r>
-              <a:rPr lang="en-US" sz="1200" b="1" spc="200" kern="0" dirty="0">
-                <a:solidFill>
-                  <a:srgbClr val="FF7300"/>
-                </a:solidFill>
-                <a:latin typeface="Calibri" pitchFamily="34" charset="0"/>
-                <a:ea typeface="Calibri" pitchFamily="34" charset="-122"/>
-                <a:cs typeface="Calibri" pitchFamily="34" charset="-120"/>
-              </a:rPr>
-              <a:t>Class 2 · 完成</a:t>
-            </a:r>
-            <a:endParaRPr lang="en-US" sz="1200" dirty="0"/>
-          </a:p>
-        </p:txBody>
-      </p:sp>
-      <p:sp>
-        <p:nvSpPr>
-          <p:cNvPr id="3" name="Text 1"/>
-          <p:cNvSpPr/>
-          <p:nvPr/>
-        </p:nvSpPr>
-        <p:spPr>
-          <a:xfrm>
-            <a:off x="548640" y="640080"/>
-            <a:ext cx="8046720" cy="1005840"/>
-          </a:xfrm>
-          <a:prstGeom prst="rect">
-            <a:avLst/>
-          </a:prstGeom>
-          <a:noFill/>
-          <a:ln/>
-        </p:spPr>
-        <p:txBody>
-          <a:bodyPr wrap="square" lIns="0" tIns="0" rIns="0" bIns="0" rtlCol="0" anchor="ctr"/>
-          <a:lstStyle/>
-          <a:p>
-            <a:pPr indent="0" marL="0">
-              <a:buNone/>
-            </a:pPr>
-            <a:r>
-              <a:rPr lang="en-US" sz="4000" b="1" dirty="0">
-                <a:solidFill>
-                  <a:srgbClr val="FFFFFF"/>
+              <a:rPr lang="en-US" sz="2800" b="1" dirty="0">
+                <a:solidFill>
+                  <a:srgbClr val="0E1B33"/>
                 </a:solidFill>
                 <a:latin typeface="Cambria" pitchFamily="34" charset="0"/>
                 <a:ea typeface="Cambria" pitchFamily="34" charset="-122"/>
                 <a:cs typeface="Cambria" pitchFamily="34" charset="-120"/>
               </a:rPr>
-              <a:t>下一步：網路、儲存、高可用</a:t>
-            </a:r>
-            <a:endParaRPr lang="en-US" sz="4000" dirty="0"/>
+              <a:t>比較：Kubernetes vs OpenShift (OCP)</a:t>
+            </a:r>
+            <a:endParaRPr lang="en-US" sz="2800" dirty="0"/>
           </a:p>
         </p:txBody>
       </p:sp>
@@ -8045,8 +9244,8 @@
         </p:nvSpPr>
         <p:spPr>
           <a:xfrm>
-            <a:off x="548640" y="1463040"/>
-            <a:ext cx="7863840" cy="822960"/>
+            <a:off x="8412480" y="320040"/>
+            <a:ext cx="548640" cy="365760"/>
           </a:xfrm>
           <a:prstGeom prst="rect">
             <a:avLst/>
@@ -8058,37 +9257,59 @@
           <a:bodyPr wrap="square" lIns="0" tIns="0" rIns="0" bIns="0" rtlCol="0" anchor="ctr"/>
           <a:lstStyle/>
           <a:p>
-            <a:pPr indent="0" marL="0">
-              <a:lnSpc>
-                <a:spcPts val="3000"/>
-              </a:lnSpc>
-              <a:buNone/>
-            </a:pPr>
-            <a:r>
-              <a:rPr lang="en-US" sz="1800" dirty="0">
-                <a:solidFill>
-                  <a:srgbClr val="CADCFC"/>
-                </a:solidFill>
-                <a:latin typeface="Calibri" pitchFamily="34" charset="0"/>
-                <a:ea typeface="Calibri" pitchFamily="34" charset="-122"/>
-                <a:cs typeface="Calibri" pitchFamily="34" charset="-120"/>
-              </a:rPr>
-              <a:t>了解 K8s 對外暴露、持久儲存與 HA 的原理。</a:t>
-            </a:r>
-            <a:endParaRPr lang="en-US" sz="1800" dirty="0"/>
-          </a:p>
-        </p:txBody>
-      </p:sp>
-      <p:sp>
-        <p:nvSpPr>
-          <p:cNvPr id="5" name="Text 3"/>
-          <p:cNvSpPr/>
-          <p:nvPr/>
-        </p:nvSpPr>
-        <p:spPr>
-          <a:xfrm>
-            <a:off x="548640" y="2926080"/>
-            <a:ext cx="7863840" cy="548640"/>
+            <a:pPr algn="r" indent="0" marL="0">
+              <a:buNone/>
+            </a:pPr>
+            <a:r>
+              <a:rPr lang="en-US" sz="1200" dirty="0">
+                <a:solidFill>
+                  <a:srgbClr val="5A6B85"/>
+                </a:solidFill>
+                <a:latin typeface="Calibri" pitchFamily="34" charset="0"/>
+                <a:ea typeface="Calibri" pitchFamily="34" charset="-122"/>
+                <a:cs typeface="Calibri" pitchFamily="34" charset="-120"/>
+              </a:rPr>
+              <a:t>9</a:t>
+            </a:r>
+            <a:endParaRPr lang="en-US" sz="1200" dirty="0"/>
+          </a:p>
+        </p:txBody>
+      </p:sp>
+      <p:sp>
+        <p:nvSpPr>
+          <p:cNvPr id="5" name="Shape 3"/>
+          <p:cNvSpPr/>
+          <p:nvPr/>
+        </p:nvSpPr>
+        <p:spPr>
+          <a:xfrm>
+            <a:off x="457200" y="1005840"/>
+            <a:ext cx="2743200" cy="475488"/>
+          </a:xfrm>
+          <a:prstGeom prst="rect">
+            <a:avLst/>
+          </a:prstGeom>
+          <a:solidFill>
+            <a:srgbClr val="0E1B33"/>
+          </a:solidFill>
+          <a:ln w="6350">
+            <a:solidFill>
+              <a:srgbClr val="D8E0EE"/>
+            </a:solidFill>
+            <a:prstDash val="solid"/>
+          </a:ln>
+        </p:spPr>
+      </p:sp>
+      <p:sp>
+        <p:nvSpPr>
+          <p:cNvPr id="6" name="Text 4"/>
+          <p:cNvSpPr/>
+          <p:nvPr/>
+        </p:nvSpPr>
+        <p:spPr>
+          <a:xfrm>
+            <a:off x="530352" y="1005840"/>
+            <a:ext cx="2596896" cy="475488"/>
           </a:xfrm>
           <a:prstGeom prst="rect">
             <a:avLst/>
@@ -8104,17 +9325,1528 @@
               <a:buNone/>
             </a:pPr>
             <a:r>
-              <a:rPr lang="en-US" sz="1400" dirty="0">
-                <a:solidFill>
-                  <a:srgbClr val="CADCFC"/>
-                </a:solidFill>
-                <a:latin typeface="Calibri" pitchFamily="34" charset="0"/>
-                <a:ea typeface="Calibri" pitchFamily="34" charset="-122"/>
-                <a:cs typeface="Calibri" pitchFamily="34" charset="-120"/>
-              </a:rPr>
-              <a:t>原理通了，接下來實作前先把基礎元件（CNI/儲存/HA）搞懂。</a:t>
-            </a:r>
-            <a:endParaRPr lang="en-US" sz="1400" dirty="0"/>
+              <a:rPr lang="en-US" sz="1100" b="1" dirty="0">
+                <a:solidFill>
+                  <a:srgbClr val="FF7300"/>
+                </a:solidFill>
+                <a:latin typeface="Calibri" pitchFamily="34" charset="0"/>
+                <a:ea typeface="Calibri" pitchFamily="34" charset="-122"/>
+                <a:cs typeface="Calibri" pitchFamily="34" charset="-120"/>
+              </a:rPr>
+              <a:t>面向</a:t>
+            </a:r>
+            <a:endParaRPr lang="en-US" sz="1100" dirty="0"/>
+          </a:p>
+        </p:txBody>
+      </p:sp>
+      <p:sp>
+        <p:nvSpPr>
+          <p:cNvPr id="7" name="Shape 5"/>
+          <p:cNvSpPr/>
+          <p:nvPr/>
+        </p:nvSpPr>
+        <p:spPr>
+          <a:xfrm>
+            <a:off x="3200400" y="1005840"/>
+            <a:ext cx="2743200" cy="475488"/>
+          </a:xfrm>
+          <a:prstGeom prst="rect">
+            <a:avLst/>
+          </a:prstGeom>
+          <a:solidFill>
+            <a:srgbClr val="0E1B33"/>
+          </a:solidFill>
+          <a:ln w="6350">
+            <a:solidFill>
+              <a:srgbClr val="D8E0EE"/>
+            </a:solidFill>
+            <a:prstDash val="solid"/>
+          </a:ln>
+        </p:spPr>
+      </p:sp>
+      <p:sp>
+        <p:nvSpPr>
+          <p:cNvPr id="8" name="Text 6"/>
+          <p:cNvSpPr/>
+          <p:nvPr/>
+        </p:nvSpPr>
+        <p:spPr>
+          <a:xfrm>
+            <a:off x="3273552" y="1005840"/>
+            <a:ext cx="2596896" cy="475488"/>
+          </a:xfrm>
+          <a:prstGeom prst="rect">
+            <a:avLst/>
+          </a:prstGeom>
+          <a:noFill/>
+          <a:ln/>
+        </p:spPr>
+        <p:txBody>
+          <a:bodyPr wrap="square" lIns="0" tIns="0" rIns="0" bIns="0" rtlCol="0" anchor="ctr"/>
+          <a:lstStyle/>
+          <a:p>
+            <a:pPr indent="0" marL="0">
+              <a:buNone/>
+            </a:pPr>
+            <a:r>
+              <a:rPr lang="en-US" sz="1100" b="1" dirty="0">
+                <a:solidFill>
+                  <a:srgbClr val="0E1B33"/>
+                </a:solidFill>
+                <a:latin typeface="Calibri" pitchFamily="34" charset="0"/>
+                <a:ea typeface="Calibri" pitchFamily="34" charset="-122"/>
+                <a:cs typeface="Calibri" pitchFamily="34" charset="-120"/>
+              </a:rPr>
+              <a:t>Vanilla Kubernetes</a:t>
+            </a:r>
+            <a:endParaRPr lang="en-US" sz="1100" dirty="0"/>
+          </a:p>
+        </p:txBody>
+      </p:sp>
+      <p:sp>
+        <p:nvSpPr>
+          <p:cNvPr id="9" name="Shape 7"/>
+          <p:cNvSpPr/>
+          <p:nvPr/>
+        </p:nvSpPr>
+        <p:spPr>
+          <a:xfrm>
+            <a:off x="5943600" y="1005840"/>
+            <a:ext cx="2743200" cy="475488"/>
+          </a:xfrm>
+          <a:prstGeom prst="rect">
+            <a:avLst/>
+          </a:prstGeom>
+          <a:solidFill>
+            <a:srgbClr val="0E1B33"/>
+          </a:solidFill>
+          <a:ln w="6350">
+            <a:solidFill>
+              <a:srgbClr val="D8E0EE"/>
+            </a:solidFill>
+            <a:prstDash val="solid"/>
+          </a:ln>
+        </p:spPr>
+      </p:sp>
+      <p:sp>
+        <p:nvSpPr>
+          <p:cNvPr id="10" name="Text 8"/>
+          <p:cNvSpPr/>
+          <p:nvPr/>
+        </p:nvSpPr>
+        <p:spPr>
+          <a:xfrm>
+            <a:off x="6016752" y="1005840"/>
+            <a:ext cx="2596896" cy="475488"/>
+          </a:xfrm>
+          <a:prstGeom prst="rect">
+            <a:avLst/>
+          </a:prstGeom>
+          <a:noFill/>
+          <a:ln/>
+        </p:spPr>
+        <p:txBody>
+          <a:bodyPr wrap="square" lIns="0" tIns="0" rIns="0" bIns="0" rtlCol="0" anchor="ctr"/>
+          <a:lstStyle/>
+          <a:p>
+            <a:pPr indent="0" marL="0">
+              <a:buNone/>
+            </a:pPr>
+            <a:r>
+              <a:rPr lang="en-US" sz="1100" b="1" dirty="0">
+                <a:solidFill>
+                  <a:srgbClr val="0E1B33"/>
+                </a:solidFill>
+                <a:latin typeface="Calibri" pitchFamily="34" charset="0"/>
+                <a:ea typeface="Calibri" pitchFamily="34" charset="-122"/>
+                <a:cs typeface="Calibri" pitchFamily="34" charset="-120"/>
+              </a:rPr>
+              <a:t>Red Hat OpenShift</a:t>
+            </a:r>
+            <a:endParaRPr lang="en-US" sz="1100" dirty="0"/>
+          </a:p>
+        </p:txBody>
+      </p:sp>
+      <p:sp>
+        <p:nvSpPr>
+          <p:cNvPr id="11" name="Shape 9"/>
+          <p:cNvSpPr/>
+          <p:nvPr/>
+        </p:nvSpPr>
+        <p:spPr>
+          <a:xfrm>
+            <a:off x="457200" y="1481328"/>
+            <a:ext cx="2743200" cy="475488"/>
+          </a:xfrm>
+          <a:prstGeom prst="rect">
+            <a:avLst/>
+          </a:prstGeom>
+          <a:solidFill>
+            <a:srgbClr val="EAF1FF"/>
+          </a:solidFill>
+          <a:ln w="6350">
+            <a:solidFill>
+              <a:srgbClr val="D8E0EE"/>
+            </a:solidFill>
+            <a:prstDash val="solid"/>
+          </a:ln>
+        </p:spPr>
+      </p:sp>
+      <p:sp>
+        <p:nvSpPr>
+          <p:cNvPr id="12" name="Text 10"/>
+          <p:cNvSpPr/>
+          <p:nvPr/>
+        </p:nvSpPr>
+        <p:spPr>
+          <a:xfrm>
+            <a:off x="530352" y="1481328"/>
+            <a:ext cx="2596896" cy="475488"/>
+          </a:xfrm>
+          <a:prstGeom prst="rect">
+            <a:avLst/>
+          </a:prstGeom>
+          <a:noFill/>
+          <a:ln/>
+        </p:spPr>
+        <p:txBody>
+          <a:bodyPr wrap="square" lIns="0" tIns="0" rIns="0" bIns="0" rtlCol="0" anchor="ctr"/>
+          <a:lstStyle/>
+          <a:p>
+            <a:pPr indent="0" marL="0">
+              <a:buNone/>
+            </a:pPr>
+            <a:r>
+              <a:rPr lang="en-US" sz="1100" b="1" dirty="0">
+                <a:solidFill>
+                  <a:srgbClr val="FF7300"/>
+                </a:solidFill>
+                <a:latin typeface="Calibri" pitchFamily="34" charset="0"/>
+                <a:ea typeface="Calibri" pitchFamily="34" charset="-122"/>
+                <a:cs typeface="Calibri" pitchFamily="34" charset="-120"/>
+              </a:rPr>
+              <a:t>核心</a:t>
+            </a:r>
+            <a:endParaRPr lang="en-US" sz="1100" dirty="0"/>
+          </a:p>
+        </p:txBody>
+      </p:sp>
+      <p:sp>
+        <p:nvSpPr>
+          <p:cNvPr id="13" name="Shape 11"/>
+          <p:cNvSpPr/>
+          <p:nvPr/>
+        </p:nvSpPr>
+        <p:spPr>
+          <a:xfrm>
+            <a:off x="3200400" y="1481328"/>
+            <a:ext cx="2743200" cy="475488"/>
+          </a:xfrm>
+          <a:prstGeom prst="rect">
+            <a:avLst/>
+          </a:prstGeom>
+          <a:solidFill>
+            <a:srgbClr val="EAF1FF"/>
+          </a:solidFill>
+          <a:ln w="6350">
+            <a:solidFill>
+              <a:srgbClr val="D8E0EE"/>
+            </a:solidFill>
+            <a:prstDash val="solid"/>
+          </a:ln>
+        </p:spPr>
+      </p:sp>
+      <p:sp>
+        <p:nvSpPr>
+          <p:cNvPr id="14" name="Text 12"/>
+          <p:cNvSpPr/>
+          <p:nvPr/>
+        </p:nvSpPr>
+        <p:spPr>
+          <a:xfrm>
+            <a:off x="3273552" y="1481328"/>
+            <a:ext cx="2596896" cy="475488"/>
+          </a:xfrm>
+          <a:prstGeom prst="rect">
+            <a:avLst/>
+          </a:prstGeom>
+          <a:noFill/>
+          <a:ln/>
+        </p:spPr>
+        <p:txBody>
+          <a:bodyPr wrap="square" lIns="0" tIns="0" rIns="0" bIns="0" rtlCol="0" anchor="ctr"/>
+          <a:lstStyle/>
+          <a:p>
+            <a:pPr indent="0" marL="0">
+              <a:buNone/>
+            </a:pPr>
+            <a:r>
+              <a:rPr lang="en-US" sz="1100" dirty="0">
+                <a:solidFill>
+                  <a:srgbClr val="1F2A3D"/>
+                </a:solidFill>
+                <a:latin typeface="Calibri" pitchFamily="34" charset="0"/>
+                <a:ea typeface="Calibri" pitchFamily="34" charset="-122"/>
+                <a:cs typeface="Calibri" pitchFamily="34" charset="-120"/>
+              </a:rPr>
+              <a:t>開源容器編排核心</a:t>
+            </a:r>
+            <a:endParaRPr lang="en-US" sz="1100" dirty="0"/>
+          </a:p>
+        </p:txBody>
+      </p:sp>
+      <p:sp>
+        <p:nvSpPr>
+          <p:cNvPr id="15" name="Shape 13"/>
+          <p:cNvSpPr/>
+          <p:nvPr/>
+        </p:nvSpPr>
+        <p:spPr>
+          <a:xfrm>
+            <a:off x="5943600" y="1481328"/>
+            <a:ext cx="2743200" cy="475488"/>
+          </a:xfrm>
+          <a:prstGeom prst="rect">
+            <a:avLst/>
+          </a:prstGeom>
+          <a:solidFill>
+            <a:srgbClr val="EAF1FF"/>
+          </a:solidFill>
+          <a:ln w="6350">
+            <a:solidFill>
+              <a:srgbClr val="D8E0EE"/>
+            </a:solidFill>
+            <a:prstDash val="solid"/>
+          </a:ln>
+        </p:spPr>
+      </p:sp>
+      <p:sp>
+        <p:nvSpPr>
+          <p:cNvPr id="16" name="Text 14"/>
+          <p:cNvSpPr/>
+          <p:nvPr/>
+        </p:nvSpPr>
+        <p:spPr>
+          <a:xfrm>
+            <a:off x="6016752" y="1481328"/>
+            <a:ext cx="2596896" cy="475488"/>
+          </a:xfrm>
+          <a:prstGeom prst="rect">
+            <a:avLst/>
+          </a:prstGeom>
+          <a:noFill/>
+          <a:ln/>
+        </p:spPr>
+        <p:txBody>
+          <a:bodyPr wrap="square" lIns="0" tIns="0" rIns="0" bIns="0" rtlCol="0" anchor="ctr"/>
+          <a:lstStyle/>
+          <a:p>
+            <a:pPr indent="0" marL="0">
+              <a:buNone/>
+            </a:pPr>
+            <a:r>
+              <a:rPr lang="en-US" sz="1100" dirty="0">
+                <a:solidFill>
+                  <a:srgbClr val="1F2A3D"/>
+                </a:solidFill>
+                <a:latin typeface="Calibri" pitchFamily="34" charset="0"/>
+                <a:ea typeface="Calibri" pitchFamily="34" charset="-122"/>
+                <a:cs typeface="Calibri" pitchFamily="34" charset="-120"/>
+              </a:rPr>
+              <a:t>企業 K8s 發行版＋支援</a:t>
+            </a:r>
+            <a:endParaRPr lang="en-US" sz="1100" dirty="0"/>
+          </a:p>
+        </p:txBody>
+      </p:sp>
+      <p:sp>
+        <p:nvSpPr>
+          <p:cNvPr id="17" name="Shape 15"/>
+          <p:cNvSpPr/>
+          <p:nvPr/>
+        </p:nvSpPr>
+        <p:spPr>
+          <a:xfrm>
+            <a:off x="457200" y="1956816"/>
+            <a:ext cx="2743200" cy="475488"/>
+          </a:xfrm>
+          <a:prstGeom prst="rect">
+            <a:avLst/>
+          </a:prstGeom>
+          <a:solidFill>
+            <a:srgbClr val="F3F6FC"/>
+          </a:solidFill>
+          <a:ln w="6350">
+            <a:solidFill>
+              <a:srgbClr val="D8E0EE"/>
+            </a:solidFill>
+            <a:prstDash val="solid"/>
+          </a:ln>
+        </p:spPr>
+      </p:sp>
+      <p:sp>
+        <p:nvSpPr>
+          <p:cNvPr id="18" name="Text 16"/>
+          <p:cNvSpPr/>
+          <p:nvPr/>
+        </p:nvSpPr>
+        <p:spPr>
+          <a:xfrm>
+            <a:off x="530352" y="1956816"/>
+            <a:ext cx="2596896" cy="475488"/>
+          </a:xfrm>
+          <a:prstGeom prst="rect">
+            <a:avLst/>
+          </a:prstGeom>
+          <a:noFill/>
+          <a:ln/>
+        </p:spPr>
+        <p:txBody>
+          <a:bodyPr wrap="square" lIns="0" tIns="0" rIns="0" bIns="0" rtlCol="0" anchor="ctr"/>
+          <a:lstStyle/>
+          <a:p>
+            <a:pPr indent="0" marL="0">
+              <a:buNone/>
+            </a:pPr>
+            <a:r>
+              <a:rPr lang="en-US" sz="1100" b="1" dirty="0">
+                <a:solidFill>
+                  <a:srgbClr val="FF7300"/>
+                </a:solidFill>
+                <a:latin typeface="Calibri" pitchFamily="34" charset="0"/>
+                <a:ea typeface="Calibri" pitchFamily="34" charset="-122"/>
+                <a:cs typeface="Calibri" pitchFamily="34" charset="-120"/>
+              </a:rPr>
+              <a:t>安裝</a:t>
+            </a:r>
+            <a:endParaRPr lang="en-US" sz="1100" dirty="0"/>
+          </a:p>
+        </p:txBody>
+      </p:sp>
+      <p:sp>
+        <p:nvSpPr>
+          <p:cNvPr id="19" name="Shape 17"/>
+          <p:cNvSpPr/>
+          <p:nvPr/>
+        </p:nvSpPr>
+        <p:spPr>
+          <a:xfrm>
+            <a:off x="3200400" y="1956816"/>
+            <a:ext cx="2743200" cy="475488"/>
+          </a:xfrm>
+          <a:prstGeom prst="rect">
+            <a:avLst/>
+          </a:prstGeom>
+          <a:solidFill>
+            <a:srgbClr val="F3F6FC"/>
+          </a:solidFill>
+          <a:ln w="6350">
+            <a:solidFill>
+              <a:srgbClr val="D8E0EE"/>
+            </a:solidFill>
+            <a:prstDash val="solid"/>
+          </a:ln>
+        </p:spPr>
+      </p:sp>
+      <p:sp>
+        <p:nvSpPr>
+          <p:cNvPr id="20" name="Text 18"/>
+          <p:cNvSpPr/>
+          <p:nvPr/>
+        </p:nvSpPr>
+        <p:spPr>
+          <a:xfrm>
+            <a:off x="3273552" y="1956816"/>
+            <a:ext cx="2596896" cy="475488"/>
+          </a:xfrm>
+          <a:prstGeom prst="rect">
+            <a:avLst/>
+          </a:prstGeom>
+          <a:noFill/>
+          <a:ln/>
+        </p:spPr>
+        <p:txBody>
+          <a:bodyPr wrap="square" lIns="0" tIns="0" rIns="0" bIns="0" rtlCol="0" anchor="ctr"/>
+          <a:lstStyle/>
+          <a:p>
+            <a:pPr indent="0" marL="0">
+              <a:buNone/>
+            </a:pPr>
+            <a:r>
+              <a:rPr lang="en-US" sz="1100" dirty="0">
+                <a:solidFill>
+                  <a:srgbClr val="1F2A3D"/>
+                </a:solidFill>
+                <a:latin typeface="Calibri" pitchFamily="34" charset="0"/>
+                <a:ea typeface="Calibri" pitchFamily="34" charset="-122"/>
+                <a:cs typeface="Calibri" pitchFamily="34" charset="-120"/>
+              </a:rPr>
+              <a:t>kubeadm / k3s（自行組裝）</a:t>
+            </a:r>
+            <a:endParaRPr lang="en-US" sz="1100" dirty="0"/>
+          </a:p>
+        </p:txBody>
+      </p:sp>
+      <p:sp>
+        <p:nvSpPr>
+          <p:cNvPr id="21" name="Shape 19"/>
+          <p:cNvSpPr/>
+          <p:nvPr/>
+        </p:nvSpPr>
+        <p:spPr>
+          <a:xfrm>
+            <a:off x="5943600" y="1956816"/>
+            <a:ext cx="2743200" cy="475488"/>
+          </a:xfrm>
+          <a:prstGeom prst="rect">
+            <a:avLst/>
+          </a:prstGeom>
+          <a:solidFill>
+            <a:srgbClr val="F3F6FC"/>
+          </a:solidFill>
+          <a:ln w="6350">
+            <a:solidFill>
+              <a:srgbClr val="D8E0EE"/>
+            </a:solidFill>
+            <a:prstDash val="solid"/>
+          </a:ln>
+        </p:spPr>
+      </p:sp>
+      <p:sp>
+        <p:nvSpPr>
+          <p:cNvPr id="22" name="Text 20"/>
+          <p:cNvSpPr/>
+          <p:nvPr/>
+        </p:nvSpPr>
+        <p:spPr>
+          <a:xfrm>
+            <a:off x="6016752" y="1956816"/>
+            <a:ext cx="2596896" cy="475488"/>
+          </a:xfrm>
+          <a:prstGeom prst="rect">
+            <a:avLst/>
+          </a:prstGeom>
+          <a:noFill/>
+          <a:ln/>
+        </p:spPr>
+        <p:txBody>
+          <a:bodyPr wrap="square" lIns="0" tIns="0" rIns="0" bIns="0" rtlCol="0" anchor="ctr"/>
+          <a:lstStyle/>
+          <a:p>
+            <a:pPr indent="0" marL="0">
+              <a:buNone/>
+            </a:pPr>
+            <a:r>
+              <a:rPr lang="en-US" sz="1100" dirty="0">
+                <a:solidFill>
+                  <a:srgbClr val="1F2A3D"/>
+                </a:solidFill>
+                <a:latin typeface="Calibri" pitchFamily="34" charset="0"/>
+                <a:ea typeface="Calibri" pitchFamily="34" charset="-122"/>
+                <a:cs typeface="Calibri" pitchFamily="34" charset="-120"/>
+              </a:rPr>
+              <a:t>openshift-install（一鍵/自動 HA）</a:t>
+            </a:r>
+            <a:endParaRPr lang="en-US" sz="1100" dirty="0"/>
+          </a:p>
+        </p:txBody>
+      </p:sp>
+      <p:sp>
+        <p:nvSpPr>
+          <p:cNvPr id="23" name="Shape 21"/>
+          <p:cNvSpPr/>
+          <p:nvPr/>
+        </p:nvSpPr>
+        <p:spPr>
+          <a:xfrm>
+            <a:off x="457200" y="2432304"/>
+            <a:ext cx="2743200" cy="475488"/>
+          </a:xfrm>
+          <a:prstGeom prst="rect">
+            <a:avLst/>
+          </a:prstGeom>
+          <a:solidFill>
+            <a:srgbClr val="EAF1FF"/>
+          </a:solidFill>
+          <a:ln w="6350">
+            <a:solidFill>
+              <a:srgbClr val="D8E0EE"/>
+            </a:solidFill>
+            <a:prstDash val="solid"/>
+          </a:ln>
+        </p:spPr>
+      </p:sp>
+      <p:sp>
+        <p:nvSpPr>
+          <p:cNvPr id="24" name="Text 22"/>
+          <p:cNvSpPr/>
+          <p:nvPr/>
+        </p:nvSpPr>
+        <p:spPr>
+          <a:xfrm>
+            <a:off x="530352" y="2432304"/>
+            <a:ext cx="2596896" cy="475488"/>
+          </a:xfrm>
+          <a:prstGeom prst="rect">
+            <a:avLst/>
+          </a:prstGeom>
+          <a:noFill/>
+          <a:ln/>
+        </p:spPr>
+        <p:txBody>
+          <a:bodyPr wrap="square" lIns="0" tIns="0" rIns="0" bIns="0" rtlCol="0" anchor="ctr"/>
+          <a:lstStyle/>
+          <a:p>
+            <a:pPr indent="0" marL="0">
+              <a:buNone/>
+            </a:pPr>
+            <a:r>
+              <a:rPr lang="en-US" sz="1100" b="1" dirty="0">
+                <a:solidFill>
+                  <a:srgbClr val="FF7300"/>
+                </a:solidFill>
+                <a:latin typeface="Calibri" pitchFamily="34" charset="0"/>
+                <a:ea typeface="Calibri" pitchFamily="34" charset="-122"/>
+                <a:cs typeface="Calibri" pitchFamily="34" charset="-120"/>
+              </a:rPr>
+              <a:t>runtime</a:t>
+            </a:r>
+            <a:endParaRPr lang="en-US" sz="1100" dirty="0"/>
+          </a:p>
+        </p:txBody>
+      </p:sp>
+      <p:sp>
+        <p:nvSpPr>
+          <p:cNvPr id="25" name="Shape 23"/>
+          <p:cNvSpPr/>
+          <p:nvPr/>
+        </p:nvSpPr>
+        <p:spPr>
+          <a:xfrm>
+            <a:off x="3200400" y="2432304"/>
+            <a:ext cx="2743200" cy="475488"/>
+          </a:xfrm>
+          <a:prstGeom prst="rect">
+            <a:avLst/>
+          </a:prstGeom>
+          <a:solidFill>
+            <a:srgbClr val="EAF1FF"/>
+          </a:solidFill>
+          <a:ln w="6350">
+            <a:solidFill>
+              <a:srgbClr val="D8E0EE"/>
+            </a:solidFill>
+            <a:prstDash val="solid"/>
+          </a:ln>
+        </p:spPr>
+      </p:sp>
+      <p:sp>
+        <p:nvSpPr>
+          <p:cNvPr id="26" name="Text 24"/>
+          <p:cNvSpPr/>
+          <p:nvPr/>
+        </p:nvSpPr>
+        <p:spPr>
+          <a:xfrm>
+            <a:off x="3273552" y="2432304"/>
+            <a:ext cx="2596896" cy="475488"/>
+          </a:xfrm>
+          <a:prstGeom prst="rect">
+            <a:avLst/>
+          </a:prstGeom>
+          <a:noFill/>
+          <a:ln/>
+        </p:spPr>
+        <p:txBody>
+          <a:bodyPr wrap="square" lIns="0" tIns="0" rIns="0" bIns="0" rtlCol="0" anchor="ctr"/>
+          <a:lstStyle/>
+          <a:p>
+            <a:pPr indent="0" marL="0">
+              <a:buNone/>
+            </a:pPr>
+            <a:r>
+              <a:rPr lang="en-US" sz="1100" dirty="0">
+                <a:solidFill>
+                  <a:srgbClr val="1F2A3D"/>
+                </a:solidFill>
+                <a:latin typeface="Calibri" pitchFamily="34" charset="0"/>
+                <a:ea typeface="Calibri" pitchFamily="34" charset="-122"/>
+                <a:cs typeface="Calibri" pitchFamily="34" charset="-120"/>
+              </a:rPr>
+              <a:t>containerd / CRI-O</a:t>
+            </a:r>
+            <a:endParaRPr lang="en-US" sz="1100" dirty="0"/>
+          </a:p>
+        </p:txBody>
+      </p:sp>
+      <p:sp>
+        <p:nvSpPr>
+          <p:cNvPr id="27" name="Shape 25"/>
+          <p:cNvSpPr/>
+          <p:nvPr/>
+        </p:nvSpPr>
+        <p:spPr>
+          <a:xfrm>
+            <a:off x="5943600" y="2432304"/>
+            <a:ext cx="2743200" cy="475488"/>
+          </a:xfrm>
+          <a:prstGeom prst="rect">
+            <a:avLst/>
+          </a:prstGeom>
+          <a:solidFill>
+            <a:srgbClr val="EAF1FF"/>
+          </a:solidFill>
+          <a:ln w="6350">
+            <a:solidFill>
+              <a:srgbClr val="D8E0EE"/>
+            </a:solidFill>
+            <a:prstDash val="solid"/>
+          </a:ln>
+        </p:spPr>
+      </p:sp>
+      <p:sp>
+        <p:nvSpPr>
+          <p:cNvPr id="28" name="Text 26"/>
+          <p:cNvSpPr/>
+          <p:nvPr/>
+        </p:nvSpPr>
+        <p:spPr>
+          <a:xfrm>
+            <a:off x="6016752" y="2432304"/>
+            <a:ext cx="2596896" cy="475488"/>
+          </a:xfrm>
+          <a:prstGeom prst="rect">
+            <a:avLst/>
+          </a:prstGeom>
+          <a:noFill/>
+          <a:ln/>
+        </p:spPr>
+        <p:txBody>
+          <a:bodyPr wrap="square" lIns="0" tIns="0" rIns="0" bIns="0" rtlCol="0" anchor="ctr"/>
+          <a:lstStyle/>
+          <a:p>
+            <a:pPr indent="0" marL="0">
+              <a:buNone/>
+            </a:pPr>
+            <a:r>
+              <a:rPr lang="en-US" sz="1100" dirty="0">
+                <a:solidFill>
+                  <a:srgbClr val="1F2A3D"/>
+                </a:solidFill>
+                <a:latin typeface="Calibri" pitchFamily="34" charset="0"/>
+                <a:ea typeface="Calibri" pitchFamily="34" charset="-122"/>
+                <a:cs typeface="Calibri" pitchFamily="34" charset="-120"/>
+              </a:rPr>
+              <a:t>CRI-O（Red Hat 主導）</a:t>
+            </a:r>
+            <a:endParaRPr lang="en-US" sz="1100" dirty="0"/>
+          </a:p>
+        </p:txBody>
+      </p:sp>
+      <p:sp>
+        <p:nvSpPr>
+          <p:cNvPr id="29" name="Shape 27"/>
+          <p:cNvSpPr/>
+          <p:nvPr/>
+        </p:nvSpPr>
+        <p:spPr>
+          <a:xfrm>
+            <a:off x="457200" y="2907792"/>
+            <a:ext cx="2743200" cy="475488"/>
+          </a:xfrm>
+          <a:prstGeom prst="rect">
+            <a:avLst/>
+          </a:prstGeom>
+          <a:solidFill>
+            <a:srgbClr val="F3F6FC"/>
+          </a:solidFill>
+          <a:ln w="6350">
+            <a:solidFill>
+              <a:srgbClr val="D8E0EE"/>
+            </a:solidFill>
+            <a:prstDash val="solid"/>
+          </a:ln>
+        </p:spPr>
+      </p:sp>
+      <p:sp>
+        <p:nvSpPr>
+          <p:cNvPr id="30" name="Text 28"/>
+          <p:cNvSpPr/>
+          <p:nvPr/>
+        </p:nvSpPr>
+        <p:spPr>
+          <a:xfrm>
+            <a:off x="530352" y="2907792"/>
+            <a:ext cx="2596896" cy="475488"/>
+          </a:xfrm>
+          <a:prstGeom prst="rect">
+            <a:avLst/>
+          </a:prstGeom>
+          <a:noFill/>
+          <a:ln/>
+        </p:spPr>
+        <p:txBody>
+          <a:bodyPr wrap="square" lIns="0" tIns="0" rIns="0" bIns="0" rtlCol="0" anchor="ctr"/>
+          <a:lstStyle/>
+          <a:p>
+            <a:pPr indent="0" marL="0">
+              <a:buNone/>
+            </a:pPr>
+            <a:r>
+              <a:rPr lang="en-US" sz="1100" b="1" dirty="0">
+                <a:solidFill>
+                  <a:srgbClr val="FF7300"/>
+                </a:solidFill>
+                <a:latin typeface="Calibri" pitchFamily="34" charset="0"/>
+                <a:ea typeface="Calibri" pitchFamily="34" charset="-122"/>
+                <a:cs typeface="Calibri" pitchFamily="34" charset="-120"/>
+              </a:rPr>
+              <a:t>節點 OS</a:t>
+            </a:r>
+            <a:endParaRPr lang="en-US" sz="1100" dirty="0"/>
+          </a:p>
+        </p:txBody>
+      </p:sp>
+      <p:sp>
+        <p:nvSpPr>
+          <p:cNvPr id="31" name="Shape 29"/>
+          <p:cNvSpPr/>
+          <p:nvPr/>
+        </p:nvSpPr>
+        <p:spPr>
+          <a:xfrm>
+            <a:off x="3200400" y="2907792"/>
+            <a:ext cx="2743200" cy="475488"/>
+          </a:xfrm>
+          <a:prstGeom prst="rect">
+            <a:avLst/>
+          </a:prstGeom>
+          <a:solidFill>
+            <a:srgbClr val="F3F6FC"/>
+          </a:solidFill>
+          <a:ln w="6350">
+            <a:solidFill>
+              <a:srgbClr val="D8E0EE"/>
+            </a:solidFill>
+            <a:prstDash val="solid"/>
+          </a:ln>
+        </p:spPr>
+      </p:sp>
+      <p:sp>
+        <p:nvSpPr>
+          <p:cNvPr id="32" name="Text 30"/>
+          <p:cNvSpPr/>
+          <p:nvPr/>
+        </p:nvSpPr>
+        <p:spPr>
+          <a:xfrm>
+            <a:off x="3273552" y="2907792"/>
+            <a:ext cx="2596896" cy="475488"/>
+          </a:xfrm>
+          <a:prstGeom prst="rect">
+            <a:avLst/>
+          </a:prstGeom>
+          <a:noFill/>
+          <a:ln/>
+        </p:spPr>
+        <p:txBody>
+          <a:bodyPr wrap="square" lIns="0" tIns="0" rIns="0" bIns="0" rtlCol="0" anchor="ctr"/>
+          <a:lstStyle/>
+          <a:p>
+            <a:pPr indent="0" marL="0">
+              <a:buNone/>
+            </a:pPr>
+            <a:r>
+              <a:rPr lang="en-US" sz="1100" dirty="0">
+                <a:solidFill>
+                  <a:srgbClr val="1F2A3D"/>
+                </a:solidFill>
+                <a:latin typeface="Calibri" pitchFamily="34" charset="0"/>
+                <a:ea typeface="Calibri" pitchFamily="34" charset="-122"/>
+                <a:cs typeface="Calibri" pitchFamily="34" charset="-120"/>
+              </a:rPr>
+              <a:t>任意 Linux</a:t>
+            </a:r>
+            <a:endParaRPr lang="en-US" sz="1100" dirty="0"/>
+          </a:p>
+        </p:txBody>
+      </p:sp>
+      <p:sp>
+        <p:nvSpPr>
+          <p:cNvPr id="33" name="Shape 31"/>
+          <p:cNvSpPr/>
+          <p:nvPr/>
+        </p:nvSpPr>
+        <p:spPr>
+          <a:xfrm>
+            <a:off x="5943600" y="2907792"/>
+            <a:ext cx="2743200" cy="475488"/>
+          </a:xfrm>
+          <a:prstGeom prst="rect">
+            <a:avLst/>
+          </a:prstGeom>
+          <a:solidFill>
+            <a:srgbClr val="F3F6FC"/>
+          </a:solidFill>
+          <a:ln w="6350">
+            <a:solidFill>
+              <a:srgbClr val="D8E0EE"/>
+            </a:solidFill>
+            <a:prstDash val="solid"/>
+          </a:ln>
+        </p:spPr>
+      </p:sp>
+      <p:sp>
+        <p:nvSpPr>
+          <p:cNvPr id="34" name="Text 32"/>
+          <p:cNvSpPr/>
+          <p:nvPr/>
+        </p:nvSpPr>
+        <p:spPr>
+          <a:xfrm>
+            <a:off x="6016752" y="2907792"/>
+            <a:ext cx="2596896" cy="475488"/>
+          </a:xfrm>
+          <a:prstGeom prst="rect">
+            <a:avLst/>
+          </a:prstGeom>
+          <a:noFill/>
+          <a:ln/>
+        </p:spPr>
+        <p:txBody>
+          <a:bodyPr wrap="square" lIns="0" tIns="0" rIns="0" bIns="0" rtlCol="0" anchor="ctr"/>
+          <a:lstStyle/>
+          <a:p>
+            <a:pPr indent="0" marL="0">
+              <a:buNone/>
+            </a:pPr>
+            <a:r>
+              <a:rPr lang="en-US" sz="1100" dirty="0">
+                <a:solidFill>
+                  <a:srgbClr val="1F2A3D"/>
+                </a:solidFill>
+                <a:latin typeface="Calibri" pitchFamily="34" charset="0"/>
+                <a:ea typeface="Calibri" pitchFamily="34" charset="-122"/>
+                <a:cs typeface="Calibri" pitchFamily="34" charset="-120"/>
+              </a:rPr>
+              <a:t>RHCOS（唯讀自動更新）</a:t>
+            </a:r>
+            <a:endParaRPr lang="en-US" sz="1100" dirty="0"/>
+          </a:p>
+        </p:txBody>
+      </p:sp>
+      <p:sp>
+        <p:nvSpPr>
+          <p:cNvPr id="35" name="Shape 33"/>
+          <p:cNvSpPr/>
+          <p:nvPr/>
+        </p:nvSpPr>
+        <p:spPr>
+          <a:xfrm>
+            <a:off x="457200" y="3383280"/>
+            <a:ext cx="2743200" cy="475488"/>
+          </a:xfrm>
+          <a:prstGeom prst="rect">
+            <a:avLst/>
+          </a:prstGeom>
+          <a:solidFill>
+            <a:srgbClr val="EAF1FF"/>
+          </a:solidFill>
+          <a:ln w="6350">
+            <a:solidFill>
+              <a:srgbClr val="D8E0EE"/>
+            </a:solidFill>
+            <a:prstDash val="solid"/>
+          </a:ln>
+        </p:spPr>
+      </p:sp>
+      <p:sp>
+        <p:nvSpPr>
+          <p:cNvPr id="36" name="Text 34"/>
+          <p:cNvSpPr/>
+          <p:nvPr/>
+        </p:nvSpPr>
+        <p:spPr>
+          <a:xfrm>
+            <a:off x="530352" y="3383280"/>
+            <a:ext cx="2596896" cy="475488"/>
+          </a:xfrm>
+          <a:prstGeom prst="rect">
+            <a:avLst/>
+          </a:prstGeom>
+          <a:noFill/>
+          <a:ln/>
+        </p:spPr>
+        <p:txBody>
+          <a:bodyPr wrap="square" lIns="0" tIns="0" rIns="0" bIns="0" rtlCol="0" anchor="ctr"/>
+          <a:lstStyle/>
+          <a:p>
+            <a:pPr indent="0" marL="0">
+              <a:buNone/>
+            </a:pPr>
+            <a:r>
+              <a:rPr lang="en-US" sz="1100" b="1" dirty="0">
+                <a:solidFill>
+                  <a:srgbClr val="FF7300"/>
+                </a:solidFill>
+                <a:latin typeface="Calibri" pitchFamily="34" charset="0"/>
+                <a:ea typeface="Calibri" pitchFamily="34" charset="-122"/>
+                <a:cs typeface="Calibri" pitchFamily="34" charset="-120"/>
+              </a:rPr>
+              <a:t>網路</a:t>
+            </a:r>
+            <a:endParaRPr lang="en-US" sz="1100" dirty="0"/>
+          </a:p>
+        </p:txBody>
+      </p:sp>
+      <p:sp>
+        <p:nvSpPr>
+          <p:cNvPr id="37" name="Shape 35"/>
+          <p:cNvSpPr/>
+          <p:nvPr/>
+        </p:nvSpPr>
+        <p:spPr>
+          <a:xfrm>
+            <a:off x="3200400" y="3383280"/>
+            <a:ext cx="2743200" cy="475488"/>
+          </a:xfrm>
+          <a:prstGeom prst="rect">
+            <a:avLst/>
+          </a:prstGeom>
+          <a:solidFill>
+            <a:srgbClr val="EAF1FF"/>
+          </a:solidFill>
+          <a:ln w="6350">
+            <a:solidFill>
+              <a:srgbClr val="D8E0EE"/>
+            </a:solidFill>
+            <a:prstDash val="solid"/>
+          </a:ln>
+        </p:spPr>
+      </p:sp>
+      <p:sp>
+        <p:nvSpPr>
+          <p:cNvPr id="38" name="Text 36"/>
+          <p:cNvSpPr/>
+          <p:nvPr/>
+        </p:nvSpPr>
+        <p:spPr>
+          <a:xfrm>
+            <a:off x="3273552" y="3383280"/>
+            <a:ext cx="2596896" cy="475488"/>
+          </a:xfrm>
+          <a:prstGeom prst="rect">
+            <a:avLst/>
+          </a:prstGeom>
+          <a:noFill/>
+          <a:ln/>
+        </p:spPr>
+        <p:txBody>
+          <a:bodyPr wrap="square" lIns="0" tIns="0" rIns="0" bIns="0" rtlCol="0" anchor="ctr"/>
+          <a:lstStyle/>
+          <a:p>
+            <a:pPr indent="0" marL="0">
+              <a:buNone/>
+            </a:pPr>
+            <a:r>
+              <a:rPr lang="en-US" sz="1100" dirty="0">
+                <a:solidFill>
+                  <a:srgbClr val="1F2A3D"/>
+                </a:solidFill>
+                <a:latin typeface="Calibri" pitchFamily="34" charset="0"/>
+                <a:ea typeface="Calibri" pitchFamily="34" charset="-122"/>
+                <a:cs typeface="Calibri" pitchFamily="34" charset="-120"/>
+              </a:rPr>
+              <a:t>自裝 CNI（Calico…）</a:t>
+            </a:r>
+            <a:endParaRPr lang="en-US" sz="1100" dirty="0"/>
+          </a:p>
+        </p:txBody>
+      </p:sp>
+      <p:sp>
+        <p:nvSpPr>
+          <p:cNvPr id="39" name="Shape 37"/>
+          <p:cNvSpPr/>
+          <p:nvPr/>
+        </p:nvSpPr>
+        <p:spPr>
+          <a:xfrm>
+            <a:off x="5943600" y="3383280"/>
+            <a:ext cx="2743200" cy="475488"/>
+          </a:xfrm>
+          <a:prstGeom prst="rect">
+            <a:avLst/>
+          </a:prstGeom>
+          <a:solidFill>
+            <a:srgbClr val="EAF1FF"/>
+          </a:solidFill>
+          <a:ln w="6350">
+            <a:solidFill>
+              <a:srgbClr val="D8E0EE"/>
+            </a:solidFill>
+            <a:prstDash val="solid"/>
+          </a:ln>
+        </p:spPr>
+      </p:sp>
+      <p:sp>
+        <p:nvSpPr>
+          <p:cNvPr id="40" name="Text 38"/>
+          <p:cNvSpPr/>
+          <p:nvPr/>
+        </p:nvSpPr>
+        <p:spPr>
+          <a:xfrm>
+            <a:off x="6016752" y="3383280"/>
+            <a:ext cx="2596896" cy="475488"/>
+          </a:xfrm>
+          <a:prstGeom prst="rect">
+            <a:avLst/>
+          </a:prstGeom>
+          <a:noFill/>
+          <a:ln/>
+        </p:spPr>
+        <p:txBody>
+          <a:bodyPr wrap="square" lIns="0" tIns="0" rIns="0" bIns="0" rtlCol="0" anchor="ctr"/>
+          <a:lstStyle/>
+          <a:p>
+            <a:pPr indent="0" marL="0">
+              <a:buNone/>
+            </a:pPr>
+            <a:r>
+              <a:rPr lang="en-US" sz="1100" dirty="0">
+                <a:solidFill>
+                  <a:srgbClr val="1F2A3D"/>
+                </a:solidFill>
+                <a:latin typeface="Calibri" pitchFamily="34" charset="0"/>
+                <a:ea typeface="Calibri" pitchFamily="34" charset="-122"/>
+                <a:cs typeface="Calibri" pitchFamily="34" charset="-120"/>
+              </a:rPr>
+              <a:t>內建 OVN-Kubernetes</a:t>
+            </a:r>
+            <a:endParaRPr lang="en-US" sz="1100" dirty="0"/>
+          </a:p>
+        </p:txBody>
+      </p:sp>
+      <p:sp>
+        <p:nvSpPr>
+          <p:cNvPr id="41" name="Shape 39"/>
+          <p:cNvSpPr/>
+          <p:nvPr/>
+        </p:nvSpPr>
+        <p:spPr>
+          <a:xfrm>
+            <a:off x="457200" y="3858768"/>
+            <a:ext cx="2743200" cy="475488"/>
+          </a:xfrm>
+          <a:prstGeom prst="rect">
+            <a:avLst/>
+          </a:prstGeom>
+          <a:solidFill>
+            <a:srgbClr val="F3F6FC"/>
+          </a:solidFill>
+          <a:ln w="6350">
+            <a:solidFill>
+              <a:srgbClr val="D8E0EE"/>
+            </a:solidFill>
+            <a:prstDash val="solid"/>
+          </a:ln>
+        </p:spPr>
+      </p:sp>
+      <p:sp>
+        <p:nvSpPr>
+          <p:cNvPr id="42" name="Text 40"/>
+          <p:cNvSpPr/>
+          <p:nvPr/>
+        </p:nvSpPr>
+        <p:spPr>
+          <a:xfrm>
+            <a:off x="530352" y="3858768"/>
+            <a:ext cx="2596896" cy="475488"/>
+          </a:xfrm>
+          <a:prstGeom prst="rect">
+            <a:avLst/>
+          </a:prstGeom>
+          <a:noFill/>
+          <a:ln/>
+        </p:spPr>
+        <p:txBody>
+          <a:bodyPr wrap="square" lIns="0" tIns="0" rIns="0" bIns="0" rtlCol="0" anchor="ctr"/>
+          <a:lstStyle/>
+          <a:p>
+            <a:pPr indent="0" marL="0">
+              <a:buNone/>
+            </a:pPr>
+            <a:r>
+              <a:rPr lang="en-US" sz="1100" b="1" dirty="0">
+                <a:solidFill>
+                  <a:srgbClr val="FF7300"/>
+                </a:solidFill>
+                <a:latin typeface="Calibri" pitchFamily="34" charset="0"/>
+                <a:ea typeface="Calibri" pitchFamily="34" charset="-122"/>
+                <a:cs typeface="Calibri" pitchFamily="34" charset="-120"/>
+              </a:rPr>
+              <a:t>認證/路由</a:t>
+            </a:r>
+            <a:endParaRPr lang="en-US" sz="1100" dirty="0"/>
+          </a:p>
+        </p:txBody>
+      </p:sp>
+      <p:sp>
+        <p:nvSpPr>
+          <p:cNvPr id="43" name="Shape 41"/>
+          <p:cNvSpPr/>
+          <p:nvPr/>
+        </p:nvSpPr>
+        <p:spPr>
+          <a:xfrm>
+            <a:off x="3200400" y="3858768"/>
+            <a:ext cx="2743200" cy="475488"/>
+          </a:xfrm>
+          <a:prstGeom prst="rect">
+            <a:avLst/>
+          </a:prstGeom>
+          <a:solidFill>
+            <a:srgbClr val="F3F6FC"/>
+          </a:solidFill>
+          <a:ln w="6350">
+            <a:solidFill>
+              <a:srgbClr val="D8E0EE"/>
+            </a:solidFill>
+            <a:prstDash val="solid"/>
+          </a:ln>
+        </p:spPr>
+      </p:sp>
+      <p:sp>
+        <p:nvSpPr>
+          <p:cNvPr id="44" name="Text 42"/>
+          <p:cNvSpPr/>
+          <p:nvPr/>
+        </p:nvSpPr>
+        <p:spPr>
+          <a:xfrm>
+            <a:off x="3273552" y="3858768"/>
+            <a:ext cx="2596896" cy="475488"/>
+          </a:xfrm>
+          <a:prstGeom prst="rect">
+            <a:avLst/>
+          </a:prstGeom>
+          <a:noFill/>
+          <a:ln/>
+        </p:spPr>
+        <p:txBody>
+          <a:bodyPr wrap="square" lIns="0" tIns="0" rIns="0" bIns="0" rtlCol="0" anchor="ctr"/>
+          <a:lstStyle/>
+          <a:p>
+            <a:pPr indent="0" marL="0">
+              <a:buNone/>
+            </a:pPr>
+            <a:r>
+              <a:rPr lang="en-US" sz="1100" dirty="0">
+                <a:solidFill>
+                  <a:srgbClr val="1F2A3D"/>
+                </a:solidFill>
+                <a:latin typeface="Calibri" pitchFamily="34" charset="0"/>
+                <a:ea typeface="Calibri" pitchFamily="34" charset="-122"/>
+                <a:cs typeface="Calibri" pitchFamily="34" charset="-120"/>
+              </a:rPr>
+              <a:t>自組 OIDC / Ingress</a:t>
+            </a:r>
+            <a:endParaRPr lang="en-US" sz="1100" dirty="0"/>
+          </a:p>
+        </p:txBody>
+      </p:sp>
+      <p:sp>
+        <p:nvSpPr>
+          <p:cNvPr id="45" name="Shape 43"/>
+          <p:cNvSpPr/>
+          <p:nvPr/>
+        </p:nvSpPr>
+        <p:spPr>
+          <a:xfrm>
+            <a:off x="5943600" y="3858768"/>
+            <a:ext cx="2743200" cy="475488"/>
+          </a:xfrm>
+          <a:prstGeom prst="rect">
+            <a:avLst/>
+          </a:prstGeom>
+          <a:solidFill>
+            <a:srgbClr val="F3F6FC"/>
+          </a:solidFill>
+          <a:ln w="6350">
+            <a:solidFill>
+              <a:srgbClr val="D8E0EE"/>
+            </a:solidFill>
+            <a:prstDash val="solid"/>
+          </a:ln>
+        </p:spPr>
+      </p:sp>
+      <p:sp>
+        <p:nvSpPr>
+          <p:cNvPr id="46" name="Text 44"/>
+          <p:cNvSpPr/>
+          <p:nvPr/>
+        </p:nvSpPr>
+        <p:spPr>
+          <a:xfrm>
+            <a:off x="6016752" y="3858768"/>
+            <a:ext cx="2596896" cy="475488"/>
+          </a:xfrm>
+          <a:prstGeom prst="rect">
+            <a:avLst/>
+          </a:prstGeom>
+          <a:noFill/>
+          <a:ln/>
+        </p:spPr>
+        <p:txBody>
+          <a:bodyPr wrap="square" lIns="0" tIns="0" rIns="0" bIns="0" rtlCol="0" anchor="ctr"/>
+          <a:lstStyle/>
+          <a:p>
+            <a:pPr indent="0" marL="0">
+              <a:buNone/>
+            </a:pPr>
+            <a:r>
+              <a:rPr lang="en-US" sz="1100" dirty="0">
+                <a:solidFill>
+                  <a:srgbClr val="1F2A3D"/>
+                </a:solidFill>
+                <a:latin typeface="Calibri" pitchFamily="34" charset="0"/>
+                <a:ea typeface="Calibri" pitchFamily="34" charset="-122"/>
+                <a:cs typeface="Calibri" pitchFamily="34" charset="-120"/>
+              </a:rPr>
+              <a:t>內建 OAuth＋Router</a:t>
+            </a:r>
+            <a:endParaRPr lang="en-US" sz="1100" dirty="0"/>
+          </a:p>
+        </p:txBody>
+      </p:sp>
+      <p:sp>
+        <p:nvSpPr>
+          <p:cNvPr id="47" name="Shape 45"/>
+          <p:cNvSpPr/>
+          <p:nvPr/>
+        </p:nvSpPr>
+        <p:spPr>
+          <a:xfrm>
+            <a:off x="457200" y="4334256"/>
+            <a:ext cx="2743200" cy="475488"/>
+          </a:xfrm>
+          <a:prstGeom prst="rect">
+            <a:avLst/>
+          </a:prstGeom>
+          <a:solidFill>
+            <a:srgbClr val="EAF1FF"/>
+          </a:solidFill>
+          <a:ln w="6350">
+            <a:solidFill>
+              <a:srgbClr val="D8E0EE"/>
+            </a:solidFill>
+            <a:prstDash val="solid"/>
+          </a:ln>
+        </p:spPr>
+      </p:sp>
+      <p:sp>
+        <p:nvSpPr>
+          <p:cNvPr id="48" name="Text 46"/>
+          <p:cNvSpPr/>
+          <p:nvPr/>
+        </p:nvSpPr>
+        <p:spPr>
+          <a:xfrm>
+            <a:off x="530352" y="4334256"/>
+            <a:ext cx="2596896" cy="475488"/>
+          </a:xfrm>
+          <a:prstGeom prst="rect">
+            <a:avLst/>
+          </a:prstGeom>
+          <a:noFill/>
+          <a:ln/>
+        </p:spPr>
+        <p:txBody>
+          <a:bodyPr wrap="square" lIns="0" tIns="0" rIns="0" bIns="0" rtlCol="0" anchor="ctr"/>
+          <a:lstStyle/>
+          <a:p>
+            <a:pPr indent="0" marL="0">
+              <a:buNone/>
+            </a:pPr>
+            <a:r>
+              <a:rPr lang="en-US" sz="1100" b="1" dirty="0">
+                <a:solidFill>
+                  <a:srgbClr val="FF7300"/>
+                </a:solidFill>
+                <a:latin typeface="Calibri" pitchFamily="34" charset="0"/>
+                <a:ea typeface="Calibri" pitchFamily="34" charset="-122"/>
+                <a:cs typeface="Calibri" pitchFamily="34" charset="-120"/>
+              </a:rPr>
+              <a:t>成本</a:t>
+            </a:r>
+            <a:endParaRPr lang="en-US" sz="1100" dirty="0"/>
+          </a:p>
+        </p:txBody>
+      </p:sp>
+      <p:sp>
+        <p:nvSpPr>
+          <p:cNvPr id="49" name="Shape 47"/>
+          <p:cNvSpPr/>
+          <p:nvPr/>
+        </p:nvSpPr>
+        <p:spPr>
+          <a:xfrm>
+            <a:off x="3200400" y="4334256"/>
+            <a:ext cx="2743200" cy="475488"/>
+          </a:xfrm>
+          <a:prstGeom prst="rect">
+            <a:avLst/>
+          </a:prstGeom>
+          <a:solidFill>
+            <a:srgbClr val="EAF1FF"/>
+          </a:solidFill>
+          <a:ln w="6350">
+            <a:solidFill>
+              <a:srgbClr val="D8E0EE"/>
+            </a:solidFill>
+            <a:prstDash val="solid"/>
+          </a:ln>
+        </p:spPr>
+      </p:sp>
+      <p:sp>
+        <p:nvSpPr>
+          <p:cNvPr id="50" name="Text 48"/>
+          <p:cNvSpPr/>
+          <p:nvPr/>
+        </p:nvSpPr>
+        <p:spPr>
+          <a:xfrm>
+            <a:off x="3273552" y="4334256"/>
+            <a:ext cx="2596896" cy="475488"/>
+          </a:xfrm>
+          <a:prstGeom prst="rect">
+            <a:avLst/>
+          </a:prstGeom>
+          <a:noFill/>
+          <a:ln/>
+        </p:spPr>
+        <p:txBody>
+          <a:bodyPr wrap="square" lIns="0" tIns="0" rIns="0" bIns="0" rtlCol="0" anchor="ctr"/>
+          <a:lstStyle/>
+          <a:p>
+            <a:pPr indent="0" marL="0">
+              <a:buNone/>
+            </a:pPr>
+            <a:r>
+              <a:rPr lang="en-US" sz="1100" dirty="0">
+                <a:solidFill>
+                  <a:srgbClr val="1F2A3D"/>
+                </a:solidFill>
+                <a:latin typeface="Calibri" pitchFamily="34" charset="0"/>
+                <a:ea typeface="Calibri" pitchFamily="34" charset="-122"/>
+                <a:cs typeface="Calibri" pitchFamily="34" charset="-120"/>
+              </a:rPr>
+              <a:t>免費開源</a:t>
+            </a:r>
+            <a:endParaRPr lang="en-US" sz="1100" dirty="0"/>
+          </a:p>
+        </p:txBody>
+      </p:sp>
+      <p:sp>
+        <p:nvSpPr>
+          <p:cNvPr id="51" name="Shape 49"/>
+          <p:cNvSpPr/>
+          <p:nvPr/>
+        </p:nvSpPr>
+        <p:spPr>
+          <a:xfrm>
+            <a:off x="5943600" y="4334256"/>
+            <a:ext cx="2743200" cy="475488"/>
+          </a:xfrm>
+          <a:prstGeom prst="rect">
+            <a:avLst/>
+          </a:prstGeom>
+          <a:solidFill>
+            <a:srgbClr val="EAF1FF"/>
+          </a:solidFill>
+          <a:ln w="6350">
+            <a:solidFill>
+              <a:srgbClr val="D8E0EE"/>
+            </a:solidFill>
+            <a:prstDash val="solid"/>
+          </a:ln>
+        </p:spPr>
+      </p:sp>
+      <p:sp>
+        <p:nvSpPr>
+          <p:cNvPr id="52" name="Text 50"/>
+          <p:cNvSpPr/>
+          <p:nvPr/>
+        </p:nvSpPr>
+        <p:spPr>
+          <a:xfrm>
+            <a:off x="6016752" y="4334256"/>
+            <a:ext cx="2596896" cy="475488"/>
+          </a:xfrm>
+          <a:prstGeom prst="rect">
+            <a:avLst/>
+          </a:prstGeom>
+          <a:noFill/>
+          <a:ln/>
+        </p:spPr>
+        <p:txBody>
+          <a:bodyPr wrap="square" lIns="0" tIns="0" rIns="0" bIns="0" rtlCol="0" anchor="ctr"/>
+          <a:lstStyle/>
+          <a:p>
+            <a:pPr indent="0" marL="0">
+              <a:buNone/>
+            </a:pPr>
+            <a:r>
+              <a:rPr lang="en-US" sz="1100" dirty="0">
+                <a:solidFill>
+                  <a:srgbClr val="1F2A3D"/>
+                </a:solidFill>
+                <a:latin typeface="Calibri" pitchFamily="34" charset="0"/>
+                <a:ea typeface="Calibri" pitchFamily="34" charset="-122"/>
+                <a:cs typeface="Calibri" pitchFamily="34" charset="-120"/>
+              </a:rPr>
+              <a:t>付費訂閱（有 SLA）</a:t>
+            </a:r>
+            <a:endParaRPr lang="en-US" sz="1100" dirty="0"/>
+          </a:p>
+        </p:txBody>
+      </p:sp>
+      <p:sp>
+        <p:nvSpPr>
+          <p:cNvPr id="53" name="Text 51"/>
+          <p:cNvSpPr/>
+          <p:nvPr/>
+        </p:nvSpPr>
+        <p:spPr>
+          <a:xfrm>
+            <a:off x="457200" y="4892040"/>
+            <a:ext cx="8229600" cy="228600"/>
+          </a:xfrm>
+          <a:prstGeom prst="rect">
+            <a:avLst/>
+          </a:prstGeom>
+          <a:noFill/>
+          <a:ln/>
+        </p:spPr>
+        <p:txBody>
+          <a:bodyPr wrap="square" lIns="0" tIns="0" rIns="0" bIns="0" rtlCol="0" anchor="ctr"/>
+          <a:lstStyle/>
+          <a:p>
+            <a:pPr indent="0" marL="0">
+              <a:buNone/>
+            </a:pPr>
+            <a:r>
+              <a:rPr lang="en-US" sz="900" dirty="0">
+                <a:solidFill>
+                  <a:srgbClr val="5A6B85"/>
+                </a:solidFill>
+                <a:latin typeface="Calibri" pitchFamily="34" charset="0"/>
+                <a:ea typeface="Calibri" pitchFamily="34" charset="-122"/>
+                <a:cs typeface="Calibri" pitchFamily="34" charset="-120"/>
+              </a:rPr>
+              <a:t>同一套 K8s API；OCP 等於「K8s 核心 + 企業層功能 + Red Hat 支援」</a:t>
+            </a:r>
+            <a:endParaRPr lang="en-US" sz="900" dirty="0"/>
           </a:p>
         </p:txBody>
       </p:sp>

</xml_diff>